<commit_message>
windows: 0917 pptx finish
</commit_message>
<xml_diff>
--- a/reports/02_work/0917汇报.pptx
+++ b/reports/02_work/0917汇报.pptx
@@ -4,15 +4,20 @@
   <p:sldMasterIdLst>
     <p:sldMasterId id="2147483648" r:id="rId1"/>
   </p:sldMasterIdLst>
+  <p:notesMasterIdLst>
+    <p:notesMasterId r:id="rId12"/>
+  </p:notesMasterIdLst>
   <p:sldIdLst>
     <p:sldId id="256" r:id="rId2"/>
     <p:sldId id="257" r:id="rId3"/>
-    <p:sldId id="263" r:id="rId4"/>
+    <p:sldId id="264" r:id="rId4"/>
     <p:sldId id="258" r:id="rId5"/>
     <p:sldId id="259" r:id="rId6"/>
     <p:sldId id="260" r:id="rId7"/>
-    <p:sldId id="261" r:id="rId8"/>
-    <p:sldId id="262" r:id="rId9"/>
+    <p:sldId id="265" r:id="rId8"/>
+    <p:sldId id="266" r:id="rId9"/>
+    <p:sldId id="261" r:id="rId10"/>
+    <p:sldId id="262" r:id="rId11"/>
   </p:sldIdLst>
   <p:sldSz cx="12192000" cy="6858000"/>
   <p:notesSz cx="6858000" cy="9144000"/>
@@ -112,6 +117,1091 @@
     </a:lvl9pPr>
   </p:defaultTextStyle>
 </p:presentation>
+</file>
+
+<file path=ppt/notesMasters/notesMaster1.xml><?xml version="1.0" encoding="utf-8"?>
+<p:notesMaster xmlns:a="http://schemas.openxmlformats.org/drawingml/2006/main" xmlns:r="http://schemas.openxmlformats.org/officeDocument/2006/relationships" xmlns:p="http://schemas.openxmlformats.org/presentationml/2006/main">
+  <p:cSld>
+    <p:bg>
+      <p:bgRef idx="1001">
+        <a:schemeClr val="bg1"/>
+      </p:bgRef>
+    </p:bg>
+    <p:spTree>
+      <p:nvGrpSpPr>
+        <p:cNvPr id="1" name=""/>
+        <p:cNvGrpSpPr/>
+        <p:nvPr/>
+      </p:nvGrpSpPr>
+      <p:grpSpPr>
+        <a:xfrm>
+          <a:off x="0" y="0"/>
+          <a:ext cx="0" cy="0"/>
+          <a:chOff x="0" y="0"/>
+          <a:chExt cx="0" cy="0"/>
+        </a:xfrm>
+      </p:grpSpPr>
+      <p:sp>
+        <p:nvSpPr>
+          <p:cNvPr id="2" name="页眉占位符 1"/>
+          <p:cNvSpPr>
+            <a:spLocks noGrp="1"/>
+          </p:cNvSpPr>
+          <p:nvPr>
+            <p:ph type="hdr" sz="quarter"/>
+          </p:nvPr>
+        </p:nvSpPr>
+        <p:spPr>
+          <a:xfrm>
+            <a:off x="0" y="0"/>
+            <a:ext cx="2971800" cy="458788"/>
+          </a:xfrm>
+          <a:prstGeom prst="rect">
+            <a:avLst/>
+          </a:prstGeom>
+        </p:spPr>
+        <p:txBody>
+          <a:bodyPr vert="horz" lIns="91440" tIns="45720" rIns="91440" bIns="45720" rtlCol="0"/>
+          <a:lstStyle>
+            <a:lvl1pPr algn="l">
+              <a:defRPr sz="1200"/>
+            </a:lvl1pPr>
+          </a:lstStyle>
+          <a:p>
+            <a:endParaRPr lang="zh-CN" altLang="en-US"/>
+          </a:p>
+        </p:txBody>
+      </p:sp>
+      <p:sp>
+        <p:nvSpPr>
+          <p:cNvPr id="3" name="日期占位符 2"/>
+          <p:cNvSpPr>
+            <a:spLocks noGrp="1"/>
+          </p:cNvSpPr>
+          <p:nvPr>
+            <p:ph type="dt" idx="1"/>
+          </p:nvPr>
+        </p:nvSpPr>
+        <p:spPr>
+          <a:xfrm>
+            <a:off x="3884613" y="0"/>
+            <a:ext cx="2971800" cy="458788"/>
+          </a:xfrm>
+          <a:prstGeom prst="rect">
+            <a:avLst/>
+          </a:prstGeom>
+        </p:spPr>
+        <p:txBody>
+          <a:bodyPr vert="horz" lIns="91440" tIns="45720" rIns="91440" bIns="45720" rtlCol="0"/>
+          <a:lstStyle>
+            <a:lvl1pPr algn="r">
+              <a:defRPr sz="1200"/>
+            </a:lvl1pPr>
+          </a:lstStyle>
+          <a:p>
+            <a:fld id="{34A9F60A-0783-482F-958C-553011456E33}" type="datetimeFigureOut">
+              <a:rPr lang="zh-CN" altLang="en-US" smtClean="0"/>
+              <a:t>2026/9/16</a:t>
+            </a:fld>
+            <a:endParaRPr lang="zh-CN" altLang="en-US"/>
+          </a:p>
+        </p:txBody>
+      </p:sp>
+      <p:sp>
+        <p:nvSpPr>
+          <p:cNvPr id="4" name="幻灯片图像占位符 3"/>
+          <p:cNvSpPr>
+            <a:spLocks noGrp="1" noRot="1" noChangeAspect="1"/>
+          </p:cNvSpPr>
+          <p:nvPr>
+            <p:ph type="sldImg" idx="2"/>
+          </p:nvPr>
+        </p:nvSpPr>
+        <p:spPr>
+          <a:xfrm>
+            <a:off x="685800" y="1143000"/>
+            <a:ext cx="5486400" cy="3086100"/>
+          </a:xfrm>
+          <a:prstGeom prst="rect">
+            <a:avLst/>
+          </a:prstGeom>
+          <a:noFill/>
+          <a:ln w="12700">
+            <a:solidFill>
+              <a:prstClr val="black"/>
+            </a:solidFill>
+          </a:ln>
+        </p:spPr>
+        <p:txBody>
+          <a:bodyPr vert="horz" lIns="91440" tIns="45720" rIns="91440" bIns="45720" rtlCol="0" anchor="ctr"/>
+          <a:lstStyle/>
+          <a:p>
+            <a:endParaRPr lang="zh-CN" altLang="en-US"/>
+          </a:p>
+        </p:txBody>
+      </p:sp>
+      <p:sp>
+        <p:nvSpPr>
+          <p:cNvPr id="5" name="备注占位符 4"/>
+          <p:cNvSpPr>
+            <a:spLocks noGrp="1"/>
+          </p:cNvSpPr>
+          <p:nvPr>
+            <p:ph type="body" sz="quarter" idx="3"/>
+          </p:nvPr>
+        </p:nvSpPr>
+        <p:spPr>
+          <a:xfrm>
+            <a:off x="685800" y="4400550"/>
+            <a:ext cx="5486400" cy="3600450"/>
+          </a:xfrm>
+          <a:prstGeom prst="rect">
+            <a:avLst/>
+          </a:prstGeom>
+        </p:spPr>
+        <p:txBody>
+          <a:bodyPr vert="horz" lIns="91440" tIns="45720" rIns="91440" bIns="45720" rtlCol="0"/>
+          <a:lstStyle/>
+          <a:p>
+            <a:pPr lvl="0"/>
+            <a:r>
+              <a:rPr lang="zh-CN" altLang="en-US"/>
+              <a:t>单击此处编辑母版文本样式</a:t>
+            </a:r>
+          </a:p>
+          <a:p>
+            <a:pPr lvl="1"/>
+            <a:r>
+              <a:rPr lang="zh-CN" altLang="en-US"/>
+              <a:t>二级</a:t>
+            </a:r>
+          </a:p>
+          <a:p>
+            <a:pPr lvl="2"/>
+            <a:r>
+              <a:rPr lang="zh-CN" altLang="en-US"/>
+              <a:t>三级</a:t>
+            </a:r>
+          </a:p>
+          <a:p>
+            <a:pPr lvl="3"/>
+            <a:r>
+              <a:rPr lang="zh-CN" altLang="en-US"/>
+              <a:t>四级</a:t>
+            </a:r>
+          </a:p>
+          <a:p>
+            <a:pPr lvl="4"/>
+            <a:r>
+              <a:rPr lang="zh-CN" altLang="en-US"/>
+              <a:t>五级</a:t>
+            </a:r>
+          </a:p>
+        </p:txBody>
+      </p:sp>
+      <p:sp>
+        <p:nvSpPr>
+          <p:cNvPr id="6" name="页脚占位符 5"/>
+          <p:cNvSpPr>
+            <a:spLocks noGrp="1"/>
+          </p:cNvSpPr>
+          <p:nvPr>
+            <p:ph type="ftr" sz="quarter" idx="4"/>
+          </p:nvPr>
+        </p:nvSpPr>
+        <p:spPr>
+          <a:xfrm>
+            <a:off x="0" y="8685213"/>
+            <a:ext cx="2971800" cy="458787"/>
+          </a:xfrm>
+          <a:prstGeom prst="rect">
+            <a:avLst/>
+          </a:prstGeom>
+        </p:spPr>
+        <p:txBody>
+          <a:bodyPr vert="horz" lIns="91440" tIns="45720" rIns="91440" bIns="45720" rtlCol="0" anchor="b"/>
+          <a:lstStyle>
+            <a:lvl1pPr algn="l">
+              <a:defRPr sz="1200"/>
+            </a:lvl1pPr>
+          </a:lstStyle>
+          <a:p>
+            <a:endParaRPr lang="zh-CN" altLang="en-US"/>
+          </a:p>
+        </p:txBody>
+      </p:sp>
+      <p:sp>
+        <p:nvSpPr>
+          <p:cNvPr id="7" name="灯片编号占位符 6"/>
+          <p:cNvSpPr>
+            <a:spLocks noGrp="1"/>
+          </p:cNvSpPr>
+          <p:nvPr>
+            <p:ph type="sldNum" sz="quarter" idx="5"/>
+          </p:nvPr>
+        </p:nvSpPr>
+        <p:spPr>
+          <a:xfrm>
+            <a:off x="3884613" y="8685213"/>
+            <a:ext cx="2971800" cy="458787"/>
+          </a:xfrm>
+          <a:prstGeom prst="rect">
+            <a:avLst/>
+          </a:prstGeom>
+        </p:spPr>
+        <p:txBody>
+          <a:bodyPr vert="horz" lIns="91440" tIns="45720" rIns="91440" bIns="45720" rtlCol="0" anchor="b"/>
+          <a:lstStyle>
+            <a:lvl1pPr algn="r">
+              <a:defRPr sz="1200"/>
+            </a:lvl1pPr>
+          </a:lstStyle>
+          <a:p>
+            <a:fld id="{EAE3C3D5-34BC-4C44-8899-411B442B07B2}" type="slidenum">
+              <a:rPr lang="zh-CN" altLang="en-US" smtClean="0"/>
+              <a:t>‹#›</a:t>
+            </a:fld>
+            <a:endParaRPr lang="zh-CN" altLang="en-US"/>
+          </a:p>
+        </p:txBody>
+      </p:sp>
+    </p:spTree>
+    <p:extLst>
+      <p:ext uri="{BB962C8B-B14F-4D97-AF65-F5344CB8AC3E}">
+        <p14:creationId xmlns:p14="http://schemas.microsoft.com/office/powerpoint/2010/main" val="3812086734"/>
+      </p:ext>
+    </p:extLst>
+  </p:cSld>
+  <p:clrMap bg1="lt1" tx1="dk1" bg2="lt2" tx2="dk2" accent1="accent1" accent2="accent2" accent3="accent3" accent4="accent4" accent5="accent5" accent6="accent6" hlink="hlink" folHlink="folHlink"/>
+  <p:notesStyle>
+    <a:lvl1pPr marL="0" algn="l" defTabSz="914400" rtl="0" eaLnBrk="1" latinLnBrk="0" hangingPunct="1">
+      <a:defRPr sz="1200" kern="1200">
+        <a:solidFill>
+          <a:schemeClr val="tx1"/>
+        </a:solidFill>
+        <a:latin typeface="+mn-lt"/>
+        <a:ea typeface="+mn-ea"/>
+        <a:cs typeface="+mn-cs"/>
+      </a:defRPr>
+    </a:lvl1pPr>
+    <a:lvl2pPr marL="457200" algn="l" defTabSz="914400" rtl="0" eaLnBrk="1" latinLnBrk="0" hangingPunct="1">
+      <a:defRPr sz="1200" kern="1200">
+        <a:solidFill>
+          <a:schemeClr val="tx1"/>
+        </a:solidFill>
+        <a:latin typeface="+mn-lt"/>
+        <a:ea typeface="+mn-ea"/>
+        <a:cs typeface="+mn-cs"/>
+      </a:defRPr>
+    </a:lvl2pPr>
+    <a:lvl3pPr marL="914400" algn="l" defTabSz="914400" rtl="0" eaLnBrk="1" latinLnBrk="0" hangingPunct="1">
+      <a:defRPr sz="1200" kern="1200">
+        <a:solidFill>
+          <a:schemeClr val="tx1"/>
+        </a:solidFill>
+        <a:latin typeface="+mn-lt"/>
+        <a:ea typeface="+mn-ea"/>
+        <a:cs typeface="+mn-cs"/>
+      </a:defRPr>
+    </a:lvl3pPr>
+    <a:lvl4pPr marL="1371600" algn="l" defTabSz="914400" rtl="0" eaLnBrk="1" latinLnBrk="0" hangingPunct="1">
+      <a:defRPr sz="1200" kern="1200">
+        <a:solidFill>
+          <a:schemeClr val="tx1"/>
+        </a:solidFill>
+        <a:latin typeface="+mn-lt"/>
+        <a:ea typeface="+mn-ea"/>
+        <a:cs typeface="+mn-cs"/>
+      </a:defRPr>
+    </a:lvl4pPr>
+    <a:lvl5pPr marL="1828800" algn="l" defTabSz="914400" rtl="0" eaLnBrk="1" latinLnBrk="0" hangingPunct="1">
+      <a:defRPr sz="1200" kern="1200">
+        <a:solidFill>
+          <a:schemeClr val="tx1"/>
+        </a:solidFill>
+        <a:latin typeface="+mn-lt"/>
+        <a:ea typeface="+mn-ea"/>
+        <a:cs typeface="+mn-cs"/>
+      </a:defRPr>
+    </a:lvl5pPr>
+    <a:lvl6pPr marL="2286000" algn="l" defTabSz="914400" rtl="0" eaLnBrk="1" latinLnBrk="0" hangingPunct="1">
+      <a:defRPr sz="1200" kern="1200">
+        <a:solidFill>
+          <a:schemeClr val="tx1"/>
+        </a:solidFill>
+        <a:latin typeface="+mn-lt"/>
+        <a:ea typeface="+mn-ea"/>
+        <a:cs typeface="+mn-cs"/>
+      </a:defRPr>
+    </a:lvl6pPr>
+    <a:lvl7pPr marL="2743200" algn="l" defTabSz="914400" rtl="0" eaLnBrk="1" latinLnBrk="0" hangingPunct="1">
+      <a:defRPr sz="1200" kern="1200">
+        <a:solidFill>
+          <a:schemeClr val="tx1"/>
+        </a:solidFill>
+        <a:latin typeface="+mn-lt"/>
+        <a:ea typeface="+mn-ea"/>
+        <a:cs typeface="+mn-cs"/>
+      </a:defRPr>
+    </a:lvl7pPr>
+    <a:lvl8pPr marL="3200400" algn="l" defTabSz="914400" rtl="0" eaLnBrk="1" latinLnBrk="0" hangingPunct="1">
+      <a:defRPr sz="1200" kern="1200">
+        <a:solidFill>
+          <a:schemeClr val="tx1"/>
+        </a:solidFill>
+        <a:latin typeface="+mn-lt"/>
+        <a:ea typeface="+mn-ea"/>
+        <a:cs typeface="+mn-cs"/>
+      </a:defRPr>
+    </a:lvl8pPr>
+    <a:lvl9pPr marL="3657600" algn="l" defTabSz="914400" rtl="0" eaLnBrk="1" latinLnBrk="0" hangingPunct="1">
+      <a:defRPr sz="1200" kern="1200">
+        <a:solidFill>
+          <a:schemeClr val="tx1"/>
+        </a:solidFill>
+        <a:latin typeface="+mn-lt"/>
+        <a:ea typeface="+mn-ea"/>
+        <a:cs typeface="+mn-cs"/>
+      </a:defRPr>
+    </a:lvl9pPr>
+  </p:notesStyle>
+</p:notesMaster>
+</file>
+
+<file path=ppt/notesSlides/notesSlide1.xml><?xml version="1.0" encoding="utf-8"?>
+<p:notes xmlns:a="http://schemas.openxmlformats.org/drawingml/2006/main" xmlns:r="http://schemas.openxmlformats.org/officeDocument/2006/relationships" xmlns:p="http://schemas.openxmlformats.org/presentationml/2006/main">
+  <p:cSld>
+    <p:spTree>
+      <p:nvGrpSpPr>
+        <p:cNvPr id="1" name=""/>
+        <p:cNvGrpSpPr/>
+        <p:nvPr/>
+      </p:nvGrpSpPr>
+      <p:grpSpPr>
+        <a:xfrm>
+          <a:off x="0" y="0"/>
+          <a:ext cx="0" cy="0"/>
+          <a:chOff x="0" y="0"/>
+          <a:chExt cx="0" cy="0"/>
+        </a:xfrm>
+      </p:grpSpPr>
+      <p:sp>
+        <p:nvSpPr>
+          <p:cNvPr id="2" name="幻灯片图像占位符 1"/>
+          <p:cNvSpPr>
+            <a:spLocks noGrp="1" noRot="1" noChangeAspect="1"/>
+          </p:cNvSpPr>
+          <p:nvPr>
+            <p:ph type="sldImg"/>
+          </p:nvPr>
+        </p:nvSpPr>
+        <p:spPr/>
+      </p:sp>
+      <p:sp>
+        <p:nvSpPr>
+          <p:cNvPr id="3" name="备注占位符 2"/>
+          <p:cNvSpPr>
+            <a:spLocks noGrp="1"/>
+          </p:cNvSpPr>
+          <p:nvPr>
+            <p:ph type="body" idx="1"/>
+          </p:nvPr>
+        </p:nvSpPr>
+        <p:spPr/>
+        <p:txBody>
+          <a:bodyPr/>
+          <a:lstStyle/>
+          <a:p>
+            <a:endParaRPr lang="zh-CN" altLang="en-US" dirty="0"/>
+          </a:p>
+        </p:txBody>
+      </p:sp>
+      <p:sp>
+        <p:nvSpPr>
+          <p:cNvPr id="4" name="灯片编号占位符 3"/>
+          <p:cNvSpPr>
+            <a:spLocks noGrp="1"/>
+          </p:cNvSpPr>
+          <p:nvPr>
+            <p:ph type="sldNum" sz="quarter" idx="5"/>
+          </p:nvPr>
+        </p:nvSpPr>
+        <p:spPr/>
+        <p:txBody>
+          <a:bodyPr/>
+          <a:lstStyle/>
+          <a:p>
+            <a:fld id="{EAE3C3D5-34BC-4C44-8899-411B442B07B2}" type="slidenum">
+              <a:rPr lang="zh-CN" altLang="en-US" smtClean="0"/>
+              <a:t>3</a:t>
+            </a:fld>
+            <a:endParaRPr lang="zh-CN" altLang="en-US"/>
+          </a:p>
+        </p:txBody>
+      </p:sp>
+    </p:spTree>
+    <p:extLst>
+      <p:ext uri="{BB962C8B-B14F-4D97-AF65-F5344CB8AC3E}">
+        <p14:creationId xmlns:p14="http://schemas.microsoft.com/office/powerpoint/2010/main" val="288299781"/>
+      </p:ext>
+    </p:extLst>
+  </p:cSld>
+  <p:clrMapOvr>
+    <a:masterClrMapping/>
+  </p:clrMapOvr>
+</p:notes>
+</file>
+
+<file path=ppt/notesSlides/notesSlide2.xml><?xml version="1.0" encoding="utf-8"?>
+<p:notes xmlns:a="http://schemas.openxmlformats.org/drawingml/2006/main" xmlns:r="http://schemas.openxmlformats.org/officeDocument/2006/relationships" xmlns:p="http://schemas.openxmlformats.org/presentationml/2006/main">
+  <p:cSld>
+    <p:spTree>
+      <p:nvGrpSpPr>
+        <p:cNvPr id="1" name=""/>
+        <p:cNvGrpSpPr/>
+        <p:nvPr/>
+      </p:nvGrpSpPr>
+      <p:grpSpPr>
+        <a:xfrm>
+          <a:off x="0" y="0"/>
+          <a:ext cx="0" cy="0"/>
+          <a:chOff x="0" y="0"/>
+          <a:chExt cx="0" cy="0"/>
+        </a:xfrm>
+      </p:grpSpPr>
+      <p:sp>
+        <p:nvSpPr>
+          <p:cNvPr id="2" name="幻灯片图像占位符 1"/>
+          <p:cNvSpPr>
+            <a:spLocks noGrp="1" noRot="1" noChangeAspect="1"/>
+          </p:cNvSpPr>
+          <p:nvPr>
+            <p:ph type="sldImg"/>
+          </p:nvPr>
+        </p:nvSpPr>
+        <p:spPr/>
+      </p:sp>
+      <p:sp>
+        <p:nvSpPr>
+          <p:cNvPr id="3" name="备注占位符 2"/>
+          <p:cNvSpPr>
+            <a:spLocks noGrp="1"/>
+          </p:cNvSpPr>
+          <p:nvPr>
+            <p:ph type="body" idx="1"/>
+          </p:nvPr>
+        </p:nvSpPr>
+        <p:spPr/>
+        <p:txBody>
+          <a:bodyPr/>
+          <a:lstStyle/>
+          <a:p>
+            <a:pPr rtl="0"/>
+            <a:r>
+              <a:rPr lang="zh-CN" altLang="zh-CN" sz="1200" kern="1200" dirty="0">
+                <a:solidFill>
+                  <a:schemeClr val="tx1"/>
+                </a:solidFill>
+                <a:latin typeface="+mn-lt"/>
+                <a:ea typeface="+mn-ea"/>
+                <a:cs typeface="+mn-cs"/>
+              </a:rPr>
+              <a:t>在哪测？      XSAI-emu，DefaultMatrixConfig 单核</a:t>
+            </a:r>
+          </a:p>
+          <a:p>
+            <a:pPr rtl="0"/>
+            <a:r>
+              <a:rPr lang="zh-CN" altLang="zh-CN" sz="1200" kern="1200" dirty="0">
+                <a:solidFill>
+                  <a:schemeClr val="tx1"/>
+                </a:solidFill>
+                <a:latin typeface="+mn-lt"/>
+                <a:ea typeface="+mn-ea"/>
+                <a:cs typeface="+mn-cs"/>
+              </a:rPr>
+              <a:t>测哪个程序？  GEMM-jki，M=N=K=16，int32</a:t>
+            </a:r>
+          </a:p>
+          <a:p>
+            <a:pPr rtl="0"/>
+            <a:r>
+              <a:rPr lang="zh-CN" altLang="zh-CN" sz="1200" kern="1200" dirty="0">
+                <a:solidFill>
+                  <a:schemeClr val="tx1"/>
+                </a:solidFill>
+                <a:latin typeface="+mn-lt"/>
+                <a:ea typeface="+mn-ea"/>
+                <a:cs typeface="+mn-cs"/>
+              </a:rPr>
+              <a:t>用什么测？    RTL counter</a:t>
+            </a:r>
+          </a:p>
+          <a:p>
+            <a:pPr rtl="0"/>
+            <a:r>
+              <a:rPr lang="zh-CN" altLang="zh-CN" sz="1200" kern="1200" dirty="0">
+                <a:solidFill>
+                  <a:schemeClr val="tx1"/>
+                </a:solidFill>
+                <a:latin typeface="+mn-lt"/>
+                <a:ea typeface="+mn-ea"/>
+                <a:cs typeface="+mn-cs"/>
+              </a:rPr>
+              <a:t>测到什么？    load_replay = 78,708 次</a:t>
+            </a:r>
+          </a:p>
+          <a:p>
+            <a:pPr rtl="0"/>
+            <a:r>
+              <a:rPr lang="zh-CN" altLang="zh-CN" sz="1200" kern="1200" dirty="0">
+                <a:solidFill>
+                  <a:schemeClr val="tx1"/>
+                </a:solidFill>
+                <a:latin typeface="+mn-lt"/>
+                <a:ea typeface="+mn-ea"/>
+                <a:cs typeface="+mn-cs"/>
+              </a:rPr>
+              <a:t>测量范围？    只统计 GEMM Kernel 指令窗口</a:t>
+            </a:r>
+          </a:p>
+          <a:p>
+            <a:pPr rtl="0"/>
+            <a:r>
+              <a:rPr lang="zh-CN" altLang="zh-CN" sz="1200" kern="1200" dirty="0">
+                <a:solidFill>
+                  <a:schemeClr val="tx1"/>
+                </a:solidFill>
+                <a:latin typeface="+mn-lt"/>
+                <a:ea typeface="+mn-ea"/>
+                <a:cs typeface="+mn-cs"/>
+              </a:rPr>
+              <a:t>如何聚合？    窗口内事件求和</a:t>
+            </a:r>
+          </a:p>
+          <a:p>
+            <a:endParaRPr lang="zh-CN" altLang="en-US" dirty="0"/>
+          </a:p>
+        </p:txBody>
+      </p:sp>
+      <p:sp>
+        <p:nvSpPr>
+          <p:cNvPr id="4" name="灯片编号占位符 3"/>
+          <p:cNvSpPr>
+            <a:spLocks noGrp="1"/>
+          </p:cNvSpPr>
+          <p:nvPr>
+            <p:ph type="sldNum" sz="quarter" idx="5"/>
+          </p:nvPr>
+        </p:nvSpPr>
+        <p:spPr/>
+        <p:txBody>
+          <a:bodyPr/>
+          <a:lstStyle/>
+          <a:p>
+            <a:fld id="{EAE3C3D5-34BC-4C44-8899-411B442B07B2}" type="slidenum">
+              <a:rPr lang="zh-CN" altLang="en-US" smtClean="0"/>
+              <a:t>4</a:t>
+            </a:fld>
+            <a:endParaRPr lang="zh-CN" altLang="en-US"/>
+          </a:p>
+        </p:txBody>
+      </p:sp>
+    </p:spTree>
+    <p:extLst>
+      <p:ext uri="{BB962C8B-B14F-4D97-AF65-F5344CB8AC3E}">
+        <p14:creationId xmlns:p14="http://schemas.microsoft.com/office/powerpoint/2010/main" val="3873977913"/>
+      </p:ext>
+    </p:extLst>
+  </p:cSld>
+  <p:clrMapOvr>
+    <a:masterClrMapping/>
+  </p:clrMapOvr>
+</p:notes>
+</file>
+
+<file path=ppt/notesSlides/notesSlide3.xml><?xml version="1.0" encoding="utf-8"?>
+<p:notes xmlns:a="http://schemas.openxmlformats.org/drawingml/2006/main" xmlns:r="http://schemas.openxmlformats.org/officeDocument/2006/relationships" xmlns:p="http://schemas.openxmlformats.org/presentationml/2006/main">
+  <p:cSld>
+    <p:spTree>
+      <p:nvGrpSpPr>
+        <p:cNvPr id="1" name=""/>
+        <p:cNvGrpSpPr/>
+        <p:nvPr/>
+      </p:nvGrpSpPr>
+      <p:grpSpPr>
+        <a:xfrm>
+          <a:off x="0" y="0"/>
+          <a:ext cx="0" cy="0"/>
+          <a:chOff x="0" y="0"/>
+          <a:chExt cx="0" cy="0"/>
+        </a:xfrm>
+      </p:grpSpPr>
+      <p:sp>
+        <p:nvSpPr>
+          <p:cNvPr id="2" name="幻灯片图像占位符 1"/>
+          <p:cNvSpPr>
+            <a:spLocks noGrp="1" noRot="1" noChangeAspect="1"/>
+          </p:cNvSpPr>
+          <p:nvPr>
+            <p:ph type="sldImg"/>
+          </p:nvPr>
+        </p:nvSpPr>
+        <p:spPr/>
+      </p:sp>
+      <p:sp>
+        <p:nvSpPr>
+          <p:cNvPr id="3" name="备注占位符 2"/>
+          <p:cNvSpPr>
+            <a:spLocks noGrp="1"/>
+          </p:cNvSpPr>
+          <p:nvPr>
+            <p:ph type="body" idx="1"/>
+          </p:nvPr>
+        </p:nvSpPr>
+        <p:spPr/>
+        <p:txBody>
+          <a:bodyPr/>
+          <a:lstStyle/>
+          <a:p>
+            <a:r>
+              <a:rPr lang="zh-CN" altLang="zh-CN" dirty="0"/>
+              <a:t>标准化证据层告诉我们，Vector单元在Kernel总周期中只有20%的时间处于活动状态。但仅凭这个数值，无法判断应该执行什么优化。如果DRAM带宽已经达到95%，同时内存依赖等待达到63%，Vector活动率低更可能是因为数据供给不足。如果带宽利用率只有30%，但Occupancy只有18%、可执行Workgroup很少，那么原因更可能是并行度不足。细粒度瓶颈诊断的作用，就是结合多项证据，把相同的性能现象区分成不同的受限原因。</a:t>
+            </a:r>
+            <a:endParaRPr lang="zh-CN" altLang="en-US" dirty="0"/>
+          </a:p>
+        </p:txBody>
+      </p:sp>
+      <p:sp>
+        <p:nvSpPr>
+          <p:cNvPr id="4" name="灯片编号占位符 3"/>
+          <p:cNvSpPr>
+            <a:spLocks noGrp="1"/>
+          </p:cNvSpPr>
+          <p:nvPr>
+            <p:ph type="sldNum" sz="quarter" idx="5"/>
+          </p:nvPr>
+        </p:nvSpPr>
+        <p:spPr/>
+        <p:txBody>
+          <a:bodyPr/>
+          <a:lstStyle/>
+          <a:p>
+            <a:fld id="{EAE3C3D5-34BC-4C44-8899-411B442B07B2}" type="slidenum">
+              <a:rPr lang="zh-CN" altLang="en-US" smtClean="0"/>
+              <a:t>6</a:t>
+            </a:fld>
+            <a:endParaRPr lang="zh-CN" altLang="en-US"/>
+          </a:p>
+        </p:txBody>
+      </p:sp>
+    </p:spTree>
+    <p:extLst>
+      <p:ext uri="{BB962C8B-B14F-4D97-AF65-F5344CB8AC3E}">
+        <p14:creationId xmlns:p14="http://schemas.microsoft.com/office/powerpoint/2010/main" val="758461469"/>
+      </p:ext>
+    </p:extLst>
+  </p:cSld>
+  <p:clrMapOvr>
+    <a:masterClrMapping/>
+  </p:clrMapOvr>
+</p:notes>
+</file>
+
+<file path=ppt/notesSlides/notesSlide4.xml><?xml version="1.0" encoding="utf-8"?>
+<p:notes xmlns:a="http://schemas.openxmlformats.org/drawingml/2006/main" xmlns:r="http://schemas.openxmlformats.org/officeDocument/2006/relationships" xmlns:p="http://schemas.openxmlformats.org/presentationml/2006/main">
+  <p:cSld>
+    <p:spTree>
+      <p:nvGrpSpPr>
+        <p:cNvPr id="1" name=""/>
+        <p:cNvGrpSpPr/>
+        <p:nvPr/>
+      </p:nvGrpSpPr>
+      <p:grpSpPr>
+        <a:xfrm>
+          <a:off x="0" y="0"/>
+          <a:ext cx="0" cy="0"/>
+          <a:chOff x="0" y="0"/>
+          <a:chExt cx="0" cy="0"/>
+        </a:xfrm>
+      </p:grpSpPr>
+      <p:sp>
+        <p:nvSpPr>
+          <p:cNvPr id="2" name="幻灯片图像占位符 1"/>
+          <p:cNvSpPr>
+            <a:spLocks noGrp="1" noRot="1" noChangeAspect="1"/>
+          </p:cNvSpPr>
+          <p:nvPr>
+            <p:ph type="sldImg"/>
+          </p:nvPr>
+        </p:nvSpPr>
+        <p:spPr/>
+      </p:sp>
+      <p:sp>
+        <p:nvSpPr>
+          <p:cNvPr id="3" name="备注占位符 2"/>
+          <p:cNvSpPr>
+            <a:spLocks noGrp="1"/>
+          </p:cNvSpPr>
+          <p:nvPr>
+            <p:ph type="body" idx="1"/>
+          </p:nvPr>
+        </p:nvSpPr>
+        <p:spPr/>
+        <p:txBody>
+          <a:bodyPr/>
+          <a:lstStyle/>
+          <a:p>
+            <a:r>
+              <a:rPr lang="zh-CN" altLang="zh-CN" dirty="0"/>
+              <a:t>cuda-optimized-skill已经实现了Profiling、预算分配、方法组合、多变体生成和自动验证闭环。HG-KDA可以复用这套执行框架。我们的研究增量集中在前面的决策过程：如何将不同芯片的Profiling信息转为标准化证据，如何诊断细粒度瓶颈，以及如何生成带条件和验证方法的动作。</a:t>
+            </a:r>
+            <a:endParaRPr lang="zh-CN" altLang="en-US" dirty="0"/>
+          </a:p>
+        </p:txBody>
+      </p:sp>
+      <p:sp>
+        <p:nvSpPr>
+          <p:cNvPr id="4" name="灯片编号占位符 3"/>
+          <p:cNvSpPr>
+            <a:spLocks noGrp="1"/>
+          </p:cNvSpPr>
+          <p:nvPr>
+            <p:ph type="sldNum" sz="quarter" idx="5"/>
+          </p:nvPr>
+        </p:nvSpPr>
+        <p:spPr/>
+        <p:txBody>
+          <a:bodyPr/>
+          <a:lstStyle/>
+          <a:p>
+            <a:fld id="{EAE3C3D5-34BC-4C44-8899-411B442B07B2}" type="slidenum">
+              <a:rPr lang="zh-CN" altLang="en-US" smtClean="0"/>
+              <a:t>8</a:t>
+            </a:fld>
+            <a:endParaRPr lang="zh-CN" altLang="en-US"/>
+          </a:p>
+        </p:txBody>
+      </p:sp>
+    </p:spTree>
+    <p:extLst>
+      <p:ext uri="{BB962C8B-B14F-4D97-AF65-F5344CB8AC3E}">
+        <p14:creationId xmlns:p14="http://schemas.microsoft.com/office/powerpoint/2010/main" val="845525915"/>
+      </p:ext>
+    </p:extLst>
+  </p:cSld>
+  <p:clrMapOvr>
+    <a:masterClrMapping/>
+  </p:clrMapOvr>
+</p:notes>
+</file>
+
+<file path=ppt/notesSlides/notesSlide5.xml><?xml version="1.0" encoding="utf-8"?>
+<p:notes xmlns:a="http://schemas.openxmlformats.org/drawingml/2006/main" xmlns:r="http://schemas.openxmlformats.org/officeDocument/2006/relationships" xmlns:p="http://schemas.openxmlformats.org/presentationml/2006/main">
+  <p:cSld>
+    <p:spTree>
+      <p:nvGrpSpPr>
+        <p:cNvPr id="1" name=""/>
+        <p:cNvGrpSpPr/>
+        <p:nvPr/>
+      </p:nvGrpSpPr>
+      <p:grpSpPr>
+        <a:xfrm>
+          <a:off x="0" y="0"/>
+          <a:ext cx="0" cy="0"/>
+          <a:chOff x="0" y="0"/>
+          <a:chExt cx="0" cy="0"/>
+        </a:xfrm>
+      </p:grpSpPr>
+      <p:sp>
+        <p:nvSpPr>
+          <p:cNvPr id="2" name="幻灯片图像占位符 1"/>
+          <p:cNvSpPr>
+            <a:spLocks noGrp="1" noRot="1" noChangeAspect="1"/>
+          </p:cNvSpPr>
+          <p:nvPr>
+            <p:ph type="sldImg"/>
+          </p:nvPr>
+        </p:nvSpPr>
+        <p:spPr/>
+      </p:sp>
+      <p:sp>
+        <p:nvSpPr>
+          <p:cNvPr id="3" name="备注占位符 2"/>
+          <p:cNvSpPr>
+            <a:spLocks noGrp="1"/>
+          </p:cNvSpPr>
+          <p:nvPr>
+            <p:ph type="body" idx="1"/>
+          </p:nvPr>
+        </p:nvSpPr>
+        <p:spPr/>
+        <p:txBody>
+          <a:bodyPr/>
+          <a:lstStyle/>
+          <a:p>
+            <a:pPr marL="0" marR="0" lvl="0" indent="0" algn="l" defTabSz="914400" rtl="0" eaLnBrk="1" fontAlgn="auto" latinLnBrk="0" hangingPunct="1">
+              <a:lnSpc>
+                <a:spcPct val="100000"/>
+              </a:lnSpc>
+              <a:spcBef>
+                <a:spcPts val="0"/>
+              </a:spcBef>
+              <a:spcAft>
+                <a:spcPts val="0"/>
+              </a:spcAft>
+              <a:buClrTx/>
+              <a:buSzTx/>
+              <a:buFontTx/>
+              <a:buNone/>
+              <a:tabLst/>
+              <a:defRPr/>
+            </a:pPr>
+            <a:r>
+              <a:rPr lang="zh-CN" altLang="en-US" dirty="0"/>
+              <a:t>厂商原始</a:t>
+            </a:r>
+            <a:r>
+              <a:rPr lang="en-US" altLang="zh-CN" dirty="0"/>
+              <a:t>profiling</a:t>
+            </a:r>
+            <a:r>
+              <a:rPr lang="zh-CN" altLang="en-US" dirty="0"/>
+              <a:t>信息</a:t>
+            </a:r>
+            <a:r>
+              <a:rPr lang="en-US" altLang="zh-CN" dirty="0"/>
+              <a:t>+</a:t>
+            </a:r>
+            <a:r>
+              <a:rPr lang="zh-CN" altLang="en-US" dirty="0"/>
+              <a:t>跨平台标准化证据：各个国产卡的</a:t>
+            </a:r>
+            <a:r>
+              <a:rPr lang="en-US" altLang="zh-CN" dirty="0"/>
+              <a:t>profiler</a:t>
+            </a:r>
+            <a:r>
+              <a:rPr lang="zh-CN" altLang="en-US" dirty="0"/>
+              <a:t>调研</a:t>
+            </a:r>
+            <a:r>
+              <a:rPr lang="en-US" altLang="zh-CN" dirty="0"/>
+              <a:t>+</a:t>
+            </a:r>
+            <a:r>
+              <a:rPr lang="zh-CN" altLang="en-US" dirty="0"/>
+              <a:t>与全集</a:t>
+            </a:r>
+            <a:r>
+              <a:rPr lang="en-US" altLang="zh-CN" dirty="0"/>
+              <a:t>XSAI/</a:t>
+            </a:r>
+            <a:r>
+              <a:rPr lang="zh-CN" altLang="en-US" dirty="0"/>
+              <a:t>成熟</a:t>
+            </a:r>
+            <a:r>
+              <a:rPr lang="en-US" altLang="zh-CN" dirty="0"/>
+              <a:t>NCU</a:t>
+            </a:r>
+            <a:r>
+              <a:rPr lang="zh-CN" altLang="en-US" dirty="0"/>
+              <a:t>对齐</a:t>
+            </a:r>
+            <a:endParaRPr lang="en-US" altLang="zh-CN" dirty="0"/>
+          </a:p>
+          <a:p>
+            <a:r>
+              <a:rPr lang="zh-CN" altLang="en-US" dirty="0"/>
+              <a:t>从</a:t>
+            </a:r>
+            <a:r>
+              <a:rPr lang="en-US" altLang="zh-CN" dirty="0"/>
+              <a:t>profiling</a:t>
+            </a:r>
+            <a:r>
+              <a:rPr lang="zh-CN" altLang="en-US" dirty="0"/>
+              <a:t>信息</a:t>
+            </a:r>
+            <a:r>
+              <a:rPr lang="en-US" altLang="zh-CN" dirty="0"/>
+              <a:t>+</a:t>
+            </a:r>
+            <a:r>
+              <a:rPr lang="zh-CN" altLang="en-US" dirty="0"/>
+              <a:t>细粒度瓶颈诊断</a:t>
+            </a:r>
+            <a:r>
+              <a:rPr lang="en-US" altLang="zh-CN" dirty="0"/>
+              <a:t>+</a:t>
+            </a:r>
+            <a:r>
+              <a:rPr lang="zh-CN" altLang="en-US" dirty="0"/>
+              <a:t>条件触发的候选动作：</a:t>
+            </a:r>
+            <a:endParaRPr lang="en-US" altLang="zh-CN" dirty="0"/>
+          </a:p>
+          <a:p>
+            <a:r>
+              <a:rPr lang="zh-CN" altLang="en-US" dirty="0"/>
+              <a:t>（</a:t>
+            </a:r>
+            <a:r>
+              <a:rPr lang="en-US" altLang="zh-CN" dirty="0"/>
+              <a:t>1</a:t>
+            </a:r>
+            <a:r>
+              <a:rPr lang="zh-CN" altLang="en-US" dirty="0"/>
+              <a:t>）详细调研</a:t>
+            </a:r>
+            <a:r>
+              <a:rPr lang="en-US" altLang="zh-CN" dirty="0" err="1"/>
+              <a:t>cuda</a:t>
+            </a:r>
+            <a:r>
+              <a:rPr lang="en-US" altLang="zh-CN" dirty="0"/>
+              <a:t>-optimized-skills</a:t>
+            </a:r>
+            <a:r>
+              <a:rPr lang="zh-CN" altLang="en-US" dirty="0"/>
+              <a:t>，迁移</a:t>
+            </a:r>
+            <a:endParaRPr lang="en-US" altLang="zh-CN" dirty="0"/>
+          </a:p>
+          <a:p>
+            <a:r>
+              <a:rPr lang="zh-CN" altLang="en-US" dirty="0"/>
+              <a:t>（</a:t>
+            </a:r>
+            <a:r>
+              <a:rPr lang="en-US" altLang="zh-CN" dirty="0"/>
+              <a:t>2</a:t>
+            </a:r>
+            <a:r>
+              <a:rPr lang="zh-CN" altLang="en-US" dirty="0"/>
+              <a:t>）映射建立（</a:t>
+            </a:r>
+            <a:r>
+              <a:rPr lang="en-US" altLang="zh-CN" dirty="0" err="1"/>
+              <a:t>XGBoost</a:t>
+            </a:r>
+            <a:r>
+              <a:rPr lang="zh-CN" altLang="en-US" dirty="0"/>
+              <a:t>模型训练</a:t>
+            </a:r>
+            <a:r>
+              <a:rPr lang="en-US" altLang="zh-CN" dirty="0"/>
+              <a:t>+SHAP</a:t>
+            </a:r>
+            <a:r>
+              <a:rPr lang="zh-CN" altLang="en-US" dirty="0"/>
+              <a:t>重要性筛选）：基于</a:t>
+            </a:r>
+            <a:r>
+              <a:rPr lang="en-US" altLang="zh-CN" dirty="0" err="1"/>
+              <a:t>FlagGems</a:t>
+            </a:r>
+            <a:r>
+              <a:rPr lang="zh-CN" altLang="en-US" dirty="0"/>
+              <a:t>真实</a:t>
+            </a:r>
+            <a:r>
+              <a:rPr lang="en-US" altLang="zh-CN" dirty="0"/>
+              <a:t>diff</a:t>
+            </a:r>
+            <a:r>
+              <a:rPr lang="zh-CN" altLang="en-US" dirty="0"/>
+              <a:t>（有无前后</a:t>
+            </a:r>
+            <a:r>
+              <a:rPr lang="en-US" altLang="zh-CN" dirty="0"/>
+              <a:t>profiling</a:t>
+            </a:r>
+            <a:r>
+              <a:rPr lang="zh-CN" altLang="en-US" dirty="0"/>
+              <a:t>数据？）</a:t>
+            </a:r>
+            <a:r>
+              <a:rPr lang="en-US" altLang="zh-CN" dirty="0"/>
+              <a:t> + XSAI</a:t>
+            </a:r>
+            <a:r>
+              <a:rPr lang="zh-CN" altLang="en-US" dirty="0"/>
+              <a:t>白盒重放（</a:t>
+            </a:r>
+            <a:r>
+              <a:rPr lang="en-US" altLang="zh-CN" dirty="0"/>
+              <a:t>profiling</a:t>
+            </a:r>
+            <a:r>
+              <a:rPr lang="zh-CN" altLang="en-US" dirty="0"/>
+              <a:t>全集到最小必要集合的科学筛选）</a:t>
+            </a:r>
+            <a:endParaRPr lang="en-US" altLang="zh-CN" dirty="0"/>
+          </a:p>
+          <a:p>
+            <a:r>
+              <a:rPr lang="zh-CN" altLang="en-US" dirty="0"/>
+              <a:t>（</a:t>
+            </a:r>
+            <a:r>
+              <a:rPr lang="en-US" altLang="zh-CN" dirty="0"/>
+              <a:t>3</a:t>
+            </a:r>
+            <a:r>
+              <a:rPr lang="zh-CN" altLang="en-US" dirty="0"/>
+              <a:t>）国产卡的映射对齐：人工专家迁移</a:t>
+            </a:r>
+            <a:r>
+              <a:rPr lang="en-US" altLang="zh-CN" dirty="0"/>
+              <a:t>/</a:t>
+            </a:r>
+            <a:r>
+              <a:rPr lang="zh-CN" altLang="en-US" dirty="0"/>
+              <a:t>迁移学习算法</a:t>
+            </a:r>
+            <a:endParaRPr lang="en-US" altLang="zh-CN" dirty="0"/>
+          </a:p>
+          <a:p>
+            <a:endParaRPr lang="zh-CN" altLang="en-US" dirty="0"/>
+          </a:p>
+        </p:txBody>
+      </p:sp>
+      <p:sp>
+        <p:nvSpPr>
+          <p:cNvPr id="4" name="灯片编号占位符 3"/>
+          <p:cNvSpPr>
+            <a:spLocks noGrp="1"/>
+          </p:cNvSpPr>
+          <p:nvPr>
+            <p:ph type="sldNum" sz="quarter" idx="5"/>
+          </p:nvPr>
+        </p:nvSpPr>
+        <p:spPr/>
+        <p:txBody>
+          <a:bodyPr/>
+          <a:lstStyle/>
+          <a:p>
+            <a:fld id="{EAE3C3D5-34BC-4C44-8899-411B442B07B2}" type="slidenum">
+              <a:rPr lang="zh-CN" altLang="en-US" smtClean="0"/>
+              <a:t>9</a:t>
+            </a:fld>
+            <a:endParaRPr lang="zh-CN" altLang="en-US"/>
+          </a:p>
+        </p:txBody>
+      </p:sp>
+    </p:spTree>
+    <p:extLst>
+      <p:ext uri="{BB962C8B-B14F-4D97-AF65-F5344CB8AC3E}">
+        <p14:creationId xmlns:p14="http://schemas.microsoft.com/office/powerpoint/2010/main" val="3617736660"/>
+      </p:ext>
+    </p:extLst>
+  </p:cSld>
+  <p:clrMapOvr>
+    <a:masterClrMapping/>
+  </p:clrMapOvr>
+</p:notes>
 </file>
 
 <file path=ppt/slideLayouts/slideLayout1.xml><?xml version="1.0" encoding="utf-8"?>
@@ -3399,6 +4489,70 @@
 </p:sld>
 </file>
 
+<file path=ppt/slides/slide10.xml><?xml version="1.0" encoding="utf-8"?>
+<p:sld xmlns:a="http://schemas.openxmlformats.org/drawingml/2006/main" xmlns:r="http://schemas.openxmlformats.org/officeDocument/2006/relationships" xmlns:p="http://schemas.openxmlformats.org/presentationml/2006/main">
+  <p:cSld>
+    <p:spTree>
+      <p:nvGrpSpPr>
+        <p:cNvPr id="1" name=""/>
+        <p:cNvGrpSpPr/>
+        <p:nvPr/>
+      </p:nvGrpSpPr>
+      <p:grpSpPr>
+        <a:xfrm>
+          <a:off x="0" y="0"/>
+          <a:ext cx="0" cy="0"/>
+          <a:chOff x="0" y="0"/>
+          <a:chExt cx="0" cy="0"/>
+        </a:xfrm>
+      </p:grpSpPr>
+      <p:sp>
+        <p:nvSpPr>
+          <p:cNvPr id="2" name="标题 1">
+            <a:extLst>
+              <a:ext uri="{FF2B5EF4-FFF2-40B4-BE49-F238E27FC236}">
+                <a16:creationId xmlns:a16="http://schemas.microsoft.com/office/drawing/2014/main" id="{933A8942-61EA-6741-E001-6B19721BDB71}"/>
+              </a:ext>
+            </a:extLst>
+          </p:cNvPr>
+          <p:cNvSpPr>
+            <a:spLocks noGrp="1"/>
+          </p:cNvSpPr>
+          <p:nvPr>
+            <p:ph type="title"/>
+          </p:nvPr>
+        </p:nvSpPr>
+        <p:spPr>
+          <a:xfrm>
+            <a:off x="882650" y="2766218"/>
+            <a:ext cx="10515600" cy="1325563"/>
+          </a:xfrm>
+        </p:spPr>
+        <p:txBody>
+          <a:bodyPr/>
+          <a:lstStyle/>
+          <a:p>
+            <a:pPr algn="ctr"/>
+            <a:r>
+              <a:rPr lang="zh-CN" altLang="en-US" dirty="0"/>
+              <a:t>请批评指正！</a:t>
+            </a:r>
+          </a:p>
+        </p:txBody>
+      </p:sp>
+    </p:spTree>
+    <p:extLst>
+      <p:ext uri="{BB962C8B-B14F-4D97-AF65-F5344CB8AC3E}">
+        <p14:creationId xmlns:p14="http://schemas.microsoft.com/office/powerpoint/2010/main" val="307437915"/>
+      </p:ext>
+    </p:extLst>
+  </p:cSld>
+  <p:clrMapOvr>
+    <a:masterClrMapping/>
+  </p:clrMapOvr>
+</p:sld>
+</file>
+
 <file path=ppt/slides/slide2.xml><?xml version="1.0" encoding="utf-8"?>
 <p:sld xmlns:a="http://schemas.openxmlformats.org/drawingml/2006/main" xmlns:r="http://schemas.openxmlformats.org/officeDocument/2006/relationships" xmlns:p="http://schemas.openxmlformats.org/presentationml/2006/main">
   <p:cSld>
@@ -3473,8 +4627,8 @@
         </p:blipFill>
         <p:spPr>
           <a:xfrm>
-            <a:off x="584446" y="2425510"/>
-            <a:ext cx="10515600" cy="3056082"/>
+            <a:off x="372611" y="2159696"/>
+            <a:ext cx="11446777" cy="3326704"/>
           </a:xfrm>
           <a:prstGeom prst="rect">
             <a:avLst/>
@@ -3499,7 +4653,13 @@
   <p:cSld>
     <p:spTree>
       <p:nvGrpSpPr>
-        <p:cNvPr id="1" name=""/>
+        <p:cNvPr id="1" name="">
+          <a:extLst>
+            <a:ext uri="{FF2B5EF4-FFF2-40B4-BE49-F238E27FC236}">
+              <a16:creationId xmlns:a16="http://schemas.microsoft.com/office/drawing/2014/main" id="{9C7CA686-69D8-8CD6-A34E-21DBCED565D9}"/>
+            </a:ext>
+          </a:extLst>
+        </p:cNvPr>
         <p:cNvGrpSpPr/>
         <p:nvPr/>
       </p:nvGrpSpPr>
@@ -3516,7 +4676,7 @@
           <p:cNvPr id="2" name="标题 1">
             <a:extLst>
               <a:ext uri="{FF2B5EF4-FFF2-40B4-BE49-F238E27FC236}">
-                <a16:creationId xmlns:a16="http://schemas.microsoft.com/office/drawing/2014/main" id="{4EE5C9B6-D41A-D015-B4D8-04C1AE8B903E}"/>
+                <a16:creationId xmlns:a16="http://schemas.microsoft.com/office/drawing/2014/main" id="{20BC16EA-E542-6D64-27D2-CBCFBBEE391B}"/>
               </a:ext>
             </a:extLst>
           </p:cNvPr>
@@ -3540,123 +4700,40 @@
           </a:p>
         </p:txBody>
       </p:sp>
-      <p:sp>
-        <p:nvSpPr>
-          <p:cNvPr id="3" name="内容占位符 2">
-            <a:extLst>
-              <a:ext uri="{FF2B5EF4-FFF2-40B4-BE49-F238E27FC236}">
-                <a16:creationId xmlns:a16="http://schemas.microsoft.com/office/drawing/2014/main" id="{780DD27E-9C83-275D-809B-59F09D3EEEDF}"/>
-              </a:ext>
-            </a:extLst>
-          </p:cNvPr>
-          <p:cNvSpPr>
-            <a:spLocks noGrp="1"/>
-          </p:cNvSpPr>
-          <p:nvPr>
-            <p:ph idx="1"/>
-          </p:nvPr>
-        </p:nvSpPr>
+      <p:pic>
+        <p:nvPicPr>
+          <p:cNvPr id="7" name="图片 6">
+            <a:extLst>
+              <a:ext uri="{FF2B5EF4-FFF2-40B4-BE49-F238E27FC236}">
+                <a16:creationId xmlns:a16="http://schemas.microsoft.com/office/drawing/2014/main" id="{1E1F7B69-92A7-D60D-4D7A-A9641B7AD705}"/>
+              </a:ext>
+            </a:extLst>
+          </p:cNvPr>
+          <p:cNvPicPr>
+            <a:picLocks noChangeAspect="1"/>
+          </p:cNvPicPr>
+          <p:nvPr/>
+        </p:nvPicPr>
+        <p:blipFill>
+          <a:blip r:embed="rId3"/>
+          <a:stretch>
+            <a:fillRect/>
+          </a:stretch>
+        </p:blipFill>
         <p:spPr>
           <a:xfrm>
-            <a:off x="838200" y="1690688"/>
-            <a:ext cx="10515600" cy="5520055"/>
+            <a:off x="110592" y="2288811"/>
+            <a:ext cx="11970815" cy="3048734"/>
           </a:xfrm>
+          <a:prstGeom prst="rect">
+            <a:avLst/>
+          </a:prstGeom>
         </p:spPr>
-        <p:txBody>
-          <a:bodyPr>
-            <a:normAutofit/>
-          </a:bodyPr>
-          <a:lstStyle/>
-          <a:p>
-            <a:r>
-              <a:rPr lang="zh-CN" altLang="en-US" dirty="0"/>
-              <a:t>厂商原始 </a:t>
-            </a:r>
-            <a:r>
-              <a:rPr lang="en-US" altLang="zh-CN" dirty="0"/>
-              <a:t>Profiling </a:t>
-            </a:r>
-            <a:r>
-              <a:rPr lang="zh-CN" altLang="en-US" dirty="0"/>
-              <a:t>数据</a:t>
-            </a:r>
-          </a:p>
-          <a:p>
-            <a:r>
-              <a:rPr lang="zh-CN" altLang="en-US" dirty="0"/>
-              <a:t>→ 跨平台标准化证据</a:t>
-            </a:r>
-          </a:p>
-          <a:p>
-            <a:r>
-              <a:rPr lang="zh-CN" altLang="en-US" dirty="0"/>
-              <a:t>→ 细粒度瓶颈诊断</a:t>
-            </a:r>
-          </a:p>
-          <a:p>
-            <a:r>
-              <a:rPr lang="zh-CN" altLang="en-US" dirty="0"/>
-              <a:t>→ 带适用条件的候选动作</a:t>
-            </a:r>
-            <a:endParaRPr lang="en-US" altLang="zh-CN" dirty="0"/>
-          </a:p>
-          <a:p>
-            <a:endParaRPr lang="en-US" altLang="zh-CN" dirty="0"/>
-          </a:p>
-          <a:p>
-            <a:r>
-              <a:rPr lang="zh-CN" altLang="en-US" dirty="0"/>
-              <a:t>测到了什么？</a:t>
-            </a:r>
-            <a:r>
-              <a:rPr lang="en-US" altLang="zh-CN" dirty="0"/>
-              <a:t>XSAI-</a:t>
-            </a:r>
-            <a:r>
-              <a:rPr lang="en-US" altLang="zh-CN" dirty="0" err="1"/>
-              <a:t>TopK</a:t>
-            </a:r>
-            <a:r>
-              <a:rPr lang="en-US" altLang="zh-CN" dirty="0"/>
-              <a:t> + </a:t>
-            </a:r>
-            <a:r>
-              <a:rPr lang="zh-CN" altLang="en-US" dirty="0"/>
-              <a:t>迁移？性能预测</a:t>
-            </a:r>
-            <a:r>
-              <a:rPr lang="en-US" altLang="zh-CN" dirty="0" err="1"/>
-              <a:t>nrmse</a:t>
-            </a:r>
-            <a:r>
-              <a:rPr lang="zh-CN" altLang="en-US" dirty="0"/>
-              <a:t>？</a:t>
-            </a:r>
-          </a:p>
-          <a:p>
-            <a:r>
-              <a:rPr lang="zh-CN" altLang="en-US" dirty="0"/>
-              <a:t>→ 如何跨平台表示？</a:t>
-            </a:r>
-          </a:p>
-          <a:p>
-            <a:r>
-              <a:rPr lang="zh-CN" altLang="en-US" dirty="0"/>
-              <a:t>→ 为什么性能受限？</a:t>
-            </a:r>
-          </a:p>
-          <a:p>
-            <a:r>
-              <a:rPr lang="zh-CN" altLang="en-US" dirty="0"/>
-              <a:t>→ 下一步可以做什么？</a:t>
-            </a:r>
-          </a:p>
-        </p:txBody>
-      </p:sp>
+      </p:pic>
     </p:spTree>
     <p:extLst>
       <p:ext uri="{BB962C8B-B14F-4D97-AF65-F5344CB8AC3E}">
-        <p14:creationId xmlns:p14="http://schemas.microsoft.com/office/powerpoint/2010/main" val="428064120"/>
+        <p14:creationId xmlns:p14="http://schemas.microsoft.com/office/powerpoint/2010/main" val="1492157124"/>
       </p:ext>
     </p:extLst>
   </p:cSld>
@@ -3706,7 +4783,7 @@
           <a:p>
             <a:r>
               <a:rPr lang="zh-CN" altLang="en-US" dirty="0"/>
-              <a:t>原始</a:t>
+              <a:t>厂商原始</a:t>
             </a:r>
             <a:r>
               <a:rPr lang="en-US" altLang="zh-CN" dirty="0"/>
@@ -3714,36 +4791,71 @@
             </a:r>
             <a:r>
               <a:rPr lang="zh-CN" altLang="en-US" dirty="0"/>
-              <a:t>信息 → 标准化证据</a:t>
-            </a:r>
-          </a:p>
-        </p:txBody>
-      </p:sp>
-      <p:sp>
-        <p:nvSpPr>
-          <p:cNvPr id="3" name="内容占位符 2">
-            <a:extLst>
-              <a:ext uri="{FF2B5EF4-FFF2-40B4-BE49-F238E27FC236}">
-                <a16:creationId xmlns:a16="http://schemas.microsoft.com/office/drawing/2014/main" id="{D3F2E3C7-C9F0-BA8E-BC9F-F76BA40FE041}"/>
-              </a:ext>
-            </a:extLst>
-          </p:cNvPr>
-          <p:cNvSpPr>
-            <a:spLocks noGrp="1"/>
-          </p:cNvSpPr>
-          <p:nvPr>
-            <p:ph idx="1"/>
-          </p:nvPr>
-        </p:nvSpPr>
-        <p:spPr/>
-        <p:txBody>
-          <a:bodyPr/>
-          <a:lstStyle/>
-          <a:p>
-            <a:endParaRPr lang="zh-CN" altLang="en-US"/>
-          </a:p>
-        </p:txBody>
-      </p:sp>
+              <a:t>信息</a:t>
+            </a:r>
+          </a:p>
+        </p:txBody>
+      </p:sp>
+      <p:pic>
+        <p:nvPicPr>
+          <p:cNvPr id="5" name="图片 4">
+            <a:extLst>
+              <a:ext uri="{FF2B5EF4-FFF2-40B4-BE49-F238E27FC236}">
+                <a16:creationId xmlns:a16="http://schemas.microsoft.com/office/drawing/2014/main" id="{D03F50A8-5AB8-8E82-B60C-5C55F98F8223}"/>
+              </a:ext>
+            </a:extLst>
+          </p:cNvPr>
+          <p:cNvPicPr>
+            <a:picLocks noChangeAspect="1"/>
+          </p:cNvPicPr>
+          <p:nvPr/>
+        </p:nvPicPr>
+        <p:blipFill>
+          <a:blip r:embed="rId3"/>
+          <a:stretch>
+            <a:fillRect/>
+          </a:stretch>
+        </p:blipFill>
+        <p:spPr>
+          <a:xfrm>
+            <a:off x="569315" y="1892276"/>
+            <a:ext cx="6466130" cy="4218036"/>
+          </a:xfrm>
+          <a:prstGeom prst="rect">
+            <a:avLst/>
+          </a:prstGeom>
+        </p:spPr>
+      </p:pic>
+      <p:pic>
+        <p:nvPicPr>
+          <p:cNvPr id="11" name="图片 10">
+            <a:extLst>
+              <a:ext uri="{FF2B5EF4-FFF2-40B4-BE49-F238E27FC236}">
+                <a16:creationId xmlns:a16="http://schemas.microsoft.com/office/drawing/2014/main" id="{D4DAE8AA-6814-5914-3058-A1161ED69C9C}"/>
+              </a:ext>
+            </a:extLst>
+          </p:cNvPr>
+          <p:cNvPicPr>
+            <a:picLocks noChangeAspect="1"/>
+          </p:cNvPicPr>
+          <p:nvPr/>
+        </p:nvPicPr>
+        <p:blipFill>
+          <a:blip r:embed="rId4"/>
+          <a:stretch>
+            <a:fillRect/>
+          </a:stretch>
+        </p:blipFill>
+        <p:spPr>
+          <a:xfrm>
+            <a:off x="7443804" y="2214643"/>
+            <a:ext cx="3704433" cy="3573302"/>
+          </a:xfrm>
+          <a:prstGeom prst="rect">
+            <a:avLst/>
+          </a:prstGeom>
+        </p:spPr>
+      </p:pic>
     </p:spTree>
     <p:extLst>
       <p:ext uri="{BB962C8B-B14F-4D97-AF65-F5344CB8AC3E}">
@@ -3797,36 +4909,95 @@
           <a:p>
             <a:r>
               <a:rPr lang="zh-CN" altLang="en-US" dirty="0"/>
-              <a:t>标准化证据 → 瓶颈诊断</a:t>
-            </a:r>
-          </a:p>
-        </p:txBody>
-      </p:sp>
-      <p:sp>
-        <p:nvSpPr>
-          <p:cNvPr id="3" name="内容占位符 2">
-            <a:extLst>
-              <a:ext uri="{FF2B5EF4-FFF2-40B4-BE49-F238E27FC236}">
-                <a16:creationId xmlns:a16="http://schemas.microsoft.com/office/drawing/2014/main" id="{1A043ACE-321F-8346-DE5D-315308E73A79}"/>
-              </a:ext>
-            </a:extLst>
-          </p:cNvPr>
-          <p:cNvSpPr>
-            <a:spLocks noGrp="1"/>
-          </p:cNvSpPr>
-          <p:nvPr>
-            <p:ph idx="1"/>
-          </p:nvPr>
-        </p:nvSpPr>
-        <p:spPr/>
-        <p:txBody>
-          <a:bodyPr/>
-          <a:lstStyle/>
-          <a:p>
-            <a:endParaRPr lang="zh-CN" altLang="en-US"/>
-          </a:p>
-        </p:txBody>
-      </p:sp>
+              <a:t>跨平台标准化证据</a:t>
+            </a:r>
+          </a:p>
+        </p:txBody>
+      </p:sp>
+      <p:pic>
+        <p:nvPicPr>
+          <p:cNvPr id="5" name="图片 4">
+            <a:extLst>
+              <a:ext uri="{FF2B5EF4-FFF2-40B4-BE49-F238E27FC236}">
+                <a16:creationId xmlns:a16="http://schemas.microsoft.com/office/drawing/2014/main" id="{778A3195-D41D-0C3D-0DFF-2BBA1B9BE37C}"/>
+              </a:ext>
+            </a:extLst>
+          </p:cNvPr>
+          <p:cNvPicPr>
+            <a:picLocks noChangeAspect="1"/>
+          </p:cNvPicPr>
+          <p:nvPr/>
+        </p:nvPicPr>
+        <p:blipFill>
+          <a:blip r:embed="rId2"/>
+          <a:stretch>
+            <a:fillRect/>
+          </a:stretch>
+        </p:blipFill>
+        <p:spPr>
+          <a:xfrm>
+            <a:off x="646814" y="2955316"/>
+            <a:ext cx="7924610" cy="3445483"/>
+          </a:xfrm>
+          <a:prstGeom prst="rect">
+            <a:avLst/>
+          </a:prstGeom>
+        </p:spPr>
+      </p:pic>
+      <p:pic>
+        <p:nvPicPr>
+          <p:cNvPr id="12" name="图片 11">
+            <a:extLst>
+              <a:ext uri="{FF2B5EF4-FFF2-40B4-BE49-F238E27FC236}">
+                <a16:creationId xmlns:a16="http://schemas.microsoft.com/office/drawing/2014/main" id="{5F22DC0F-C690-E08A-BA06-89F1238238A6}"/>
+              </a:ext>
+            </a:extLst>
+          </p:cNvPr>
+          <p:cNvPicPr>
+            <a:picLocks noChangeAspect="1"/>
+          </p:cNvPicPr>
+          <p:nvPr/>
+        </p:nvPicPr>
+        <p:blipFill>
+          <a:blip r:embed="rId3"/>
+          <a:stretch>
+            <a:fillRect/>
+          </a:stretch>
+        </p:blipFill>
+        <p:spPr>
+          <a:xfrm>
+            <a:off x="6778557" y="324158"/>
+            <a:ext cx="4640810" cy="3275865"/>
+          </a:xfrm>
+          <a:prstGeom prst="roundRect">
+            <a:avLst>
+              <a:gd name="adj" fmla="val 16667"/>
+            </a:avLst>
+          </a:prstGeom>
+          <a:ln>
+            <a:noFill/>
+          </a:ln>
+          <a:effectLst>
+            <a:outerShdw blurRad="76200" dist="38100" dir="7800000" algn="tl" rotWithShape="0">
+              <a:srgbClr val="000000">
+                <a:alpha val="40000"/>
+              </a:srgbClr>
+            </a:outerShdw>
+          </a:effectLst>
+          <a:scene3d>
+            <a:camera prst="orthographicFront"/>
+            <a:lightRig rig="contrasting" dir="t">
+              <a:rot lat="0" lon="0" rev="4200000"/>
+            </a:lightRig>
+          </a:scene3d>
+          <a:sp3d prstMaterial="plastic">
+            <a:bevelT w="381000" h="114300" prst="relaxedInset"/>
+            <a:contourClr>
+              <a:srgbClr val="969696"/>
+            </a:contourClr>
+          </a:sp3d>
+        </p:spPr>
+      </p:pic>
     </p:spTree>
     <p:extLst>
       <p:ext uri="{BB962C8B-B14F-4D97-AF65-F5344CB8AC3E}">
@@ -3880,36 +5051,41 @@
           <a:p>
             <a:r>
               <a:rPr lang="zh-CN" altLang="en-US" dirty="0"/>
-              <a:t>瓶颈诊断 → 候选动作</a:t>
-            </a:r>
-          </a:p>
-        </p:txBody>
-      </p:sp>
-      <p:sp>
-        <p:nvSpPr>
-          <p:cNvPr id="3" name="内容占位符 2">
-            <a:extLst>
-              <a:ext uri="{FF2B5EF4-FFF2-40B4-BE49-F238E27FC236}">
-                <a16:creationId xmlns:a16="http://schemas.microsoft.com/office/drawing/2014/main" id="{C0D77C86-8500-9D33-043E-E105476269A2}"/>
-              </a:ext>
-            </a:extLst>
-          </p:cNvPr>
-          <p:cNvSpPr>
-            <a:spLocks noGrp="1"/>
-          </p:cNvSpPr>
-          <p:nvPr>
-            <p:ph idx="1"/>
-          </p:nvPr>
-        </p:nvSpPr>
-        <p:spPr/>
-        <p:txBody>
-          <a:bodyPr/>
-          <a:lstStyle/>
-          <a:p>
-            <a:endParaRPr lang="zh-CN" altLang="en-US" dirty="0"/>
-          </a:p>
-        </p:txBody>
-      </p:sp>
+              <a:t>细粒度瓶颈诊断</a:t>
+            </a:r>
+          </a:p>
+        </p:txBody>
+      </p:sp>
+      <p:pic>
+        <p:nvPicPr>
+          <p:cNvPr id="5" name="图片 4">
+            <a:extLst>
+              <a:ext uri="{FF2B5EF4-FFF2-40B4-BE49-F238E27FC236}">
+                <a16:creationId xmlns:a16="http://schemas.microsoft.com/office/drawing/2014/main" id="{47D1C902-DF88-40F4-2EFC-94E909F51DDA}"/>
+              </a:ext>
+            </a:extLst>
+          </p:cNvPr>
+          <p:cNvPicPr>
+            <a:picLocks noChangeAspect="1"/>
+          </p:cNvPicPr>
+          <p:nvPr/>
+        </p:nvPicPr>
+        <p:blipFill>
+          <a:blip r:embed="rId3"/>
+          <a:stretch>
+            <a:fillRect/>
+          </a:stretch>
+        </p:blipFill>
+        <p:spPr>
+          <a:xfrm>
+            <a:off x="838200" y="2105247"/>
+            <a:ext cx="10397905" cy="3413052"/>
+          </a:xfrm>
+          <a:prstGeom prst="rect">
+            <a:avLst/>
+          </a:prstGeom>
+        </p:spPr>
+      </p:pic>
     </p:spTree>
     <p:extLst>
       <p:ext uri="{BB962C8B-B14F-4D97-AF65-F5344CB8AC3E}">
@@ -3940,12 +5116,42 @@
           <a:chExt cx="0" cy="0"/>
         </a:xfrm>
       </p:grpSpPr>
+      <p:pic>
+        <p:nvPicPr>
+          <p:cNvPr id="11" name="图片 10">
+            <a:extLst>
+              <a:ext uri="{FF2B5EF4-FFF2-40B4-BE49-F238E27FC236}">
+                <a16:creationId xmlns:a16="http://schemas.microsoft.com/office/drawing/2014/main" id="{3E6A0A3D-9D73-BB54-26CA-FDC5A036510F}"/>
+              </a:ext>
+            </a:extLst>
+          </p:cNvPr>
+          <p:cNvPicPr>
+            <a:picLocks noChangeAspect="1"/>
+          </p:cNvPicPr>
+          <p:nvPr/>
+        </p:nvPicPr>
+        <p:blipFill>
+          <a:blip r:embed="rId2"/>
+          <a:stretch>
+            <a:fillRect/>
+          </a:stretch>
+        </p:blipFill>
+        <p:spPr>
+          <a:xfrm>
+            <a:off x="70451" y="2133567"/>
+            <a:ext cx="12051097" cy="4280217"/>
+          </a:xfrm>
+          <a:prstGeom prst="rect">
+            <a:avLst/>
+          </a:prstGeom>
+        </p:spPr>
+      </p:pic>
       <p:sp>
         <p:nvSpPr>
           <p:cNvPr id="2" name="标题 1">
             <a:extLst>
               <a:ext uri="{FF2B5EF4-FFF2-40B4-BE49-F238E27FC236}">
-                <a16:creationId xmlns:a16="http://schemas.microsoft.com/office/drawing/2014/main" id="{14DBD51F-3C48-7850-1502-93D385F40BA6}"/>
+                <a16:creationId xmlns:a16="http://schemas.microsoft.com/office/drawing/2014/main" id="{46B7D8CF-E116-A5E9-4176-9A89620C62D1}"/>
               </a:ext>
             </a:extLst>
           </p:cNvPr>
@@ -3956,109 +5162,505 @@
             <p:ph type="title"/>
           </p:nvPr>
         </p:nvSpPr>
-        <p:spPr/>
-        <p:txBody>
-          <a:bodyPr/>
-          <a:lstStyle/>
-          <a:p>
-            <a:r>
-              <a:rPr lang="en-US" altLang="zh-CN" dirty="0"/>
-              <a:t>TODO</a:t>
-            </a:r>
-            <a:endParaRPr lang="zh-CN" altLang="en-US" dirty="0"/>
-          </a:p>
-        </p:txBody>
-      </p:sp>
-      <p:sp>
-        <p:nvSpPr>
-          <p:cNvPr id="3" name="内容占位符 2">
-            <a:extLst>
-              <a:ext uri="{FF2B5EF4-FFF2-40B4-BE49-F238E27FC236}">
-                <a16:creationId xmlns:a16="http://schemas.microsoft.com/office/drawing/2014/main" id="{5BBC1504-63C9-9883-52D6-DAAB4B59CF25}"/>
-              </a:ext>
-            </a:extLst>
-          </p:cNvPr>
-          <p:cNvSpPr>
-            <a:spLocks noGrp="1"/>
-          </p:cNvSpPr>
+        <p:spPr>
+          <a:xfrm>
+            <a:off x="838200" y="359808"/>
+            <a:ext cx="10515600" cy="1325563"/>
+          </a:xfrm>
+        </p:spPr>
+        <p:txBody>
+          <a:bodyPr/>
+          <a:lstStyle/>
+          <a:p>
+            <a:r>
+              <a:rPr lang="zh-CN" altLang="en-US" dirty="0"/>
+              <a:t>条件触发的候选动作</a:t>
+            </a:r>
+          </a:p>
+        </p:txBody>
+      </p:sp>
+      <p:graphicFrame>
+        <p:nvGraphicFramePr>
+          <p:cNvPr id="4" name="内容占位符 3">
+            <a:extLst>
+              <a:ext uri="{FF2B5EF4-FFF2-40B4-BE49-F238E27FC236}">
+                <a16:creationId xmlns:a16="http://schemas.microsoft.com/office/drawing/2014/main" id="{8EC973B3-9D23-22C1-8A23-9686395ED77D}"/>
+              </a:ext>
+            </a:extLst>
+          </p:cNvPr>
+          <p:cNvGraphicFramePr>
+            <a:graphicFrameLocks noGrp="1"/>
+          </p:cNvGraphicFramePr>
           <p:nvPr>
             <p:ph idx="1"/>
-          </p:nvPr>
-        </p:nvSpPr>
-        <p:spPr/>
-        <p:txBody>
-          <a:bodyPr/>
-          <a:lstStyle/>
-          <a:p>
-            <a:r>
-              <a:rPr lang="zh-CN" altLang="en-US" dirty="0"/>
-              <a:t>原始</a:t>
-            </a:r>
-            <a:r>
-              <a:rPr lang="en-US" altLang="zh-CN" dirty="0"/>
-              <a:t>profiling</a:t>
-            </a:r>
-            <a:r>
-              <a:rPr lang="zh-CN" altLang="en-US" dirty="0"/>
-              <a:t>信息 → 标准化证据</a:t>
-            </a:r>
-            <a:endParaRPr lang="en-US" altLang="zh-CN" dirty="0"/>
-          </a:p>
-          <a:p>
-            <a:r>
-              <a:rPr lang="zh-CN" altLang="en-US" dirty="0"/>
-              <a:t>标准化证据 → 瓶颈诊断</a:t>
-            </a:r>
-            <a:endParaRPr lang="en-US" altLang="zh-CN" dirty="0"/>
-          </a:p>
-          <a:p>
-            <a:r>
-              <a:rPr lang="zh-CN" altLang="en-US" dirty="0"/>
-              <a:t>瓶颈诊断 → 候选动作</a:t>
-            </a:r>
-            <a:endParaRPr lang="en-US" altLang="zh-CN" dirty="0"/>
-          </a:p>
-          <a:p>
-            <a:endParaRPr lang="en-US" altLang="zh-CN" dirty="0"/>
-          </a:p>
-          <a:p>
-            <a:r>
-              <a:rPr lang="en-US" altLang="zh-CN" dirty="0"/>
-              <a:t>XSAI-emu</a:t>
-            </a:r>
-            <a:r>
-              <a:rPr lang="zh-CN" altLang="en-US" dirty="0"/>
-              <a:t>：白盒提供从全集到最小必要集合的科学筛选，以及映射建立和矫正</a:t>
-            </a:r>
-            <a:endParaRPr lang="en-US" altLang="zh-CN" dirty="0"/>
-          </a:p>
-          <a:p>
-            <a:r>
-              <a:rPr lang="en-US" altLang="zh-CN" dirty="0" err="1"/>
-              <a:t>KernelGen</a:t>
-            </a:r>
-            <a:r>
-              <a:rPr lang="zh-CN" altLang="en-US" dirty="0"/>
-              <a:t>现有的框架，避免重复模块</a:t>
-            </a:r>
-            <a:endParaRPr lang="en-US" altLang="zh-CN" dirty="0"/>
-          </a:p>
-          <a:p>
-            <a:r>
-              <a:rPr lang="en-US" altLang="zh-CN" dirty="0" err="1"/>
-              <a:t>FlagGems</a:t>
-            </a:r>
-            <a:r>
-              <a:rPr lang="zh-CN" altLang="en-US" dirty="0"/>
-              <a:t>之前的迭代历史，用于提炼映射</a:t>
-            </a:r>
-          </a:p>
-        </p:txBody>
-      </p:sp>
+            <p:extLst>
+              <p:ext uri="{D42A27DB-BD31-4B8C-83A1-F6EECF244321}">
+                <p14:modId xmlns:p14="http://schemas.microsoft.com/office/powerpoint/2010/main" val="3693772973"/>
+              </p:ext>
+            </p:extLst>
+          </p:nvPr>
+        </p:nvGraphicFramePr>
+        <p:xfrm>
+          <a:off x="7384312" y="636090"/>
+          <a:ext cx="4268972" cy="1828800"/>
+        </p:xfrm>
+        <a:graphic>
+          <a:graphicData uri="http://schemas.openxmlformats.org/drawingml/2006/table">
+            <a:tbl>
+              <a:tblPr>
+                <a:tableStyleId>{5C22544A-7EE6-4342-B048-85BDC9FD1C3A}</a:tableStyleId>
+              </a:tblPr>
+              <a:tblGrid>
+                <a:gridCol w="904653">
+                  <a:extLst>
+                    <a:ext uri="{9D8B030D-6E8A-4147-A177-3AD203B41FA5}">
+                      <a16:colId xmlns:a16="http://schemas.microsoft.com/office/drawing/2014/main" val="1902638233"/>
+                    </a:ext>
+                  </a:extLst>
+                </a:gridCol>
+                <a:gridCol w="1158063">
+                  <a:extLst>
+                    <a:ext uri="{9D8B030D-6E8A-4147-A177-3AD203B41FA5}">
+                      <a16:colId xmlns:a16="http://schemas.microsoft.com/office/drawing/2014/main" val="3827289799"/>
+                    </a:ext>
+                  </a:extLst>
+                </a:gridCol>
+                <a:gridCol w="1355651">
+                  <a:extLst>
+                    <a:ext uri="{9D8B030D-6E8A-4147-A177-3AD203B41FA5}">
+                      <a16:colId xmlns:a16="http://schemas.microsoft.com/office/drawing/2014/main" val="3576617589"/>
+                    </a:ext>
+                  </a:extLst>
+                </a:gridCol>
+                <a:gridCol w="850605">
+                  <a:extLst>
+                    <a:ext uri="{9D8B030D-6E8A-4147-A177-3AD203B41FA5}">
+                      <a16:colId xmlns:a16="http://schemas.microsoft.com/office/drawing/2014/main" val="1879718522"/>
+                    </a:ext>
+                  </a:extLst>
+                </a:gridCol>
+              </a:tblGrid>
+              <a:tr h="0">
+                <a:tc>
+                  <a:txBody>
+                    <a:bodyPr/>
+                    <a:lstStyle/>
+                    <a:p>
+                      <a:pPr>
+                        <a:buNone/>
+                      </a:pPr>
+                      <a:r>
+                        <a:rPr lang="zh-CN"/>
+                        <a:t>变体</a:t>
+                      </a:r>
+                    </a:p>
+                  </a:txBody>
+                  <a:tcPr anchor="ctr">
+                    <a:solidFill>
+                      <a:schemeClr val="accent1">
+                        <a:lumMod val="60000"/>
+                        <a:lumOff val="40000"/>
+                      </a:schemeClr>
+                    </a:solidFill>
+                  </a:tcPr>
+                </a:tc>
+                <a:tc>
+                  <a:txBody>
+                    <a:bodyPr/>
+                    <a:lstStyle/>
+                    <a:p>
+                      <a:pPr>
+                        <a:buNone/>
+                      </a:pPr>
+                      <a:r>
+                        <a:rPr lang="zh-CN"/>
+                        <a:t>Tile</a:t>
+                      </a:r>
+                    </a:p>
+                  </a:txBody>
+                  <a:tcPr anchor="ctr">
+                    <a:solidFill>
+                      <a:schemeClr val="accent1">
+                        <a:lumMod val="60000"/>
+                        <a:lumOff val="40000"/>
+                      </a:schemeClr>
+                    </a:solidFill>
+                  </a:tcPr>
+                </a:tc>
+                <a:tc>
+                  <a:txBody>
+                    <a:bodyPr/>
+                    <a:lstStyle/>
+                    <a:p>
+                      <a:pPr>
+                        <a:buNone/>
+                      </a:pPr>
+                      <a:r>
+                        <a:rPr lang="zh-CN"/>
+                        <a:t>Pipeline</a:t>
+                      </a:r>
+                    </a:p>
+                  </a:txBody>
+                  <a:tcPr anchor="ctr">
+                    <a:solidFill>
+                      <a:schemeClr val="accent1">
+                        <a:lumMod val="60000"/>
+                        <a:lumOff val="40000"/>
+                      </a:schemeClr>
+                    </a:solidFill>
+                  </a:tcPr>
+                </a:tc>
+                <a:tc>
+                  <a:txBody>
+                    <a:bodyPr/>
+                    <a:lstStyle/>
+                    <a:p>
+                      <a:pPr>
+                        <a:buNone/>
+                      </a:pPr>
+                      <a:r>
+                        <a:rPr lang="zh-CN" dirty="0"/>
+                        <a:t>Unroll</a:t>
+                      </a:r>
+                    </a:p>
+                  </a:txBody>
+                  <a:tcPr anchor="ctr">
+                    <a:solidFill>
+                      <a:schemeClr val="accent1">
+                        <a:lumMod val="60000"/>
+                        <a:lumOff val="40000"/>
+                      </a:schemeClr>
+                    </a:solidFill>
+                  </a:tcPr>
+                </a:tc>
+                <a:extLst>
+                  <a:ext uri="{0D108BD9-81ED-4DB2-BD59-A6C34878D82A}">
+                    <a16:rowId xmlns:a16="http://schemas.microsoft.com/office/drawing/2014/main" val="2293831649"/>
+                  </a:ext>
+                </a:extLst>
+              </a:tr>
+              <a:tr h="0">
+                <a:tc>
+                  <a:txBody>
+                    <a:bodyPr/>
+                    <a:lstStyle/>
+                    <a:p>
+                      <a:pPr>
+                        <a:buNone/>
+                      </a:pPr>
+                      <a:r>
+                        <a:rPr lang="zh-CN"/>
+                        <a:t>v1</a:t>
+                      </a:r>
+                    </a:p>
+                  </a:txBody>
+                  <a:tcPr anchor="ctr"/>
+                </a:tc>
+                <a:tc>
+                  <a:txBody>
+                    <a:bodyPr/>
+                    <a:lstStyle/>
+                    <a:p>
+                      <a:pPr>
+                        <a:buNone/>
+                      </a:pPr>
+                      <a:r>
+                        <a:rPr lang="zh-CN"/>
+                        <a:t>64×64</a:t>
+                      </a:r>
+                    </a:p>
+                  </a:txBody>
+                  <a:tcPr anchor="ctr"/>
+                </a:tc>
+                <a:tc>
+                  <a:txBody>
+                    <a:bodyPr/>
+                    <a:lstStyle/>
+                    <a:p>
+                      <a:pPr>
+                        <a:buNone/>
+                      </a:pPr>
+                      <a:r>
+                        <a:rPr lang="zh-CN"/>
+                        <a:t>2 stages</a:t>
+                      </a:r>
+                    </a:p>
+                  </a:txBody>
+                  <a:tcPr anchor="ctr"/>
+                </a:tc>
+                <a:tc>
+                  <a:txBody>
+                    <a:bodyPr/>
+                    <a:lstStyle/>
+                    <a:p>
+                      <a:pPr>
+                        <a:buNone/>
+                      </a:pPr>
+                      <a:r>
+                        <a:rPr lang="zh-CN" dirty="0"/>
+                        <a:t>1</a:t>
+                      </a:r>
+                    </a:p>
+                  </a:txBody>
+                  <a:tcPr anchor="ctr"/>
+                </a:tc>
+                <a:extLst>
+                  <a:ext uri="{0D108BD9-81ED-4DB2-BD59-A6C34878D82A}">
+                    <a16:rowId xmlns:a16="http://schemas.microsoft.com/office/drawing/2014/main" val="3717427902"/>
+                  </a:ext>
+                </a:extLst>
+              </a:tr>
+              <a:tr h="0">
+                <a:tc>
+                  <a:txBody>
+                    <a:bodyPr/>
+                    <a:lstStyle/>
+                    <a:p>
+                      <a:pPr>
+                        <a:buNone/>
+                      </a:pPr>
+                      <a:r>
+                        <a:rPr lang="zh-CN"/>
+                        <a:t>v2</a:t>
+                      </a:r>
+                    </a:p>
+                  </a:txBody>
+                  <a:tcPr anchor="ctr"/>
+                </a:tc>
+                <a:tc>
+                  <a:txBody>
+                    <a:bodyPr/>
+                    <a:lstStyle/>
+                    <a:p>
+                      <a:pPr>
+                        <a:buNone/>
+                      </a:pPr>
+                      <a:r>
+                        <a:rPr lang="zh-CN"/>
+                        <a:t>128×64</a:t>
+                      </a:r>
+                    </a:p>
+                  </a:txBody>
+                  <a:tcPr anchor="ctr"/>
+                </a:tc>
+                <a:tc>
+                  <a:txBody>
+                    <a:bodyPr/>
+                    <a:lstStyle/>
+                    <a:p>
+                      <a:pPr>
+                        <a:buNone/>
+                      </a:pPr>
+                      <a:r>
+                        <a:rPr lang="zh-CN"/>
+                        <a:t>2 stages</a:t>
+                      </a:r>
+                    </a:p>
+                  </a:txBody>
+                  <a:tcPr anchor="ctr"/>
+                </a:tc>
+                <a:tc>
+                  <a:txBody>
+                    <a:bodyPr/>
+                    <a:lstStyle/>
+                    <a:p>
+                      <a:pPr>
+                        <a:buNone/>
+                      </a:pPr>
+                      <a:r>
+                        <a:rPr lang="zh-CN"/>
+                        <a:t>1</a:t>
+                      </a:r>
+                    </a:p>
+                  </a:txBody>
+                  <a:tcPr anchor="ctr"/>
+                </a:tc>
+                <a:extLst>
+                  <a:ext uri="{0D108BD9-81ED-4DB2-BD59-A6C34878D82A}">
+                    <a16:rowId xmlns:a16="http://schemas.microsoft.com/office/drawing/2014/main" val="1277967568"/>
+                  </a:ext>
+                </a:extLst>
+              </a:tr>
+              <a:tr h="0">
+                <a:tc>
+                  <a:txBody>
+                    <a:bodyPr/>
+                    <a:lstStyle/>
+                    <a:p>
+                      <a:pPr>
+                        <a:buNone/>
+                      </a:pPr>
+                      <a:r>
+                        <a:rPr lang="zh-CN"/>
+                        <a:t>v3</a:t>
+                      </a:r>
+                    </a:p>
+                  </a:txBody>
+                  <a:tcPr anchor="ctr"/>
+                </a:tc>
+                <a:tc>
+                  <a:txBody>
+                    <a:bodyPr/>
+                    <a:lstStyle/>
+                    <a:p>
+                      <a:pPr>
+                        <a:buNone/>
+                      </a:pPr>
+                      <a:r>
+                        <a:rPr lang="zh-CN"/>
+                        <a:t>128×128</a:t>
+                      </a:r>
+                    </a:p>
+                  </a:txBody>
+                  <a:tcPr anchor="ctr"/>
+                </a:tc>
+                <a:tc>
+                  <a:txBody>
+                    <a:bodyPr/>
+                    <a:lstStyle/>
+                    <a:p>
+                      <a:pPr>
+                        <a:buNone/>
+                      </a:pPr>
+                      <a:r>
+                        <a:rPr lang="zh-CN"/>
+                        <a:t>3 stages</a:t>
+                      </a:r>
+                    </a:p>
+                  </a:txBody>
+                  <a:tcPr anchor="ctr"/>
+                </a:tc>
+                <a:tc>
+                  <a:txBody>
+                    <a:bodyPr/>
+                    <a:lstStyle/>
+                    <a:p>
+                      <a:pPr>
+                        <a:buNone/>
+                      </a:pPr>
+                      <a:r>
+                        <a:rPr lang="zh-CN"/>
+                        <a:t>2</a:t>
+                      </a:r>
+                    </a:p>
+                  </a:txBody>
+                  <a:tcPr anchor="ctr"/>
+                </a:tc>
+                <a:extLst>
+                  <a:ext uri="{0D108BD9-81ED-4DB2-BD59-A6C34878D82A}">
+                    <a16:rowId xmlns:a16="http://schemas.microsoft.com/office/drawing/2014/main" val="2851122728"/>
+                  </a:ext>
+                </a:extLst>
+              </a:tr>
+              <a:tr h="0">
+                <a:tc>
+                  <a:txBody>
+                    <a:bodyPr/>
+                    <a:lstStyle/>
+                    <a:p>
+                      <a:pPr>
+                        <a:buNone/>
+                      </a:pPr>
+                      <a:r>
+                        <a:rPr lang="zh-CN"/>
+                        <a:t>v4</a:t>
+                      </a:r>
+                    </a:p>
+                  </a:txBody>
+                  <a:tcPr anchor="ctr"/>
+                </a:tc>
+                <a:tc>
+                  <a:txBody>
+                    <a:bodyPr/>
+                    <a:lstStyle/>
+                    <a:p>
+                      <a:pPr>
+                        <a:buNone/>
+                      </a:pPr>
+                      <a:r>
+                        <a:rPr lang="zh-CN"/>
+                        <a:t>64×128</a:t>
+                      </a:r>
+                    </a:p>
+                  </a:txBody>
+                  <a:tcPr anchor="ctr"/>
+                </a:tc>
+                <a:tc>
+                  <a:txBody>
+                    <a:bodyPr/>
+                    <a:lstStyle/>
+                    <a:p>
+                      <a:pPr>
+                        <a:buNone/>
+                      </a:pPr>
+                      <a:r>
+                        <a:rPr lang="zh-CN"/>
+                        <a:t>4 stages</a:t>
+                      </a:r>
+                    </a:p>
+                  </a:txBody>
+                  <a:tcPr anchor="ctr"/>
+                </a:tc>
+                <a:tc>
+                  <a:txBody>
+                    <a:bodyPr/>
+                    <a:lstStyle/>
+                    <a:p>
+                      <a:pPr>
+                        <a:buNone/>
+                      </a:pPr>
+                      <a:r>
+                        <a:rPr lang="zh-CN" dirty="0"/>
+                        <a:t>2</a:t>
+                      </a:r>
+                    </a:p>
+                  </a:txBody>
+                  <a:tcPr anchor="ctr"/>
+                </a:tc>
+                <a:extLst>
+                  <a:ext uri="{0D108BD9-81ED-4DB2-BD59-A6C34878D82A}">
+                    <a16:rowId xmlns:a16="http://schemas.microsoft.com/office/drawing/2014/main" val="1768560809"/>
+                  </a:ext>
+                </a:extLst>
+              </a:tr>
+            </a:tbl>
+          </a:graphicData>
+        </a:graphic>
+      </p:graphicFrame>
+      <p:pic>
+        <p:nvPicPr>
+          <p:cNvPr id="13" name="图片 12">
+            <a:extLst>
+              <a:ext uri="{FF2B5EF4-FFF2-40B4-BE49-F238E27FC236}">
+                <a16:creationId xmlns:a16="http://schemas.microsoft.com/office/drawing/2014/main" id="{A300A8C9-68FC-39C0-77FB-6B41B4BF61EC}"/>
+              </a:ext>
+            </a:extLst>
+          </p:cNvPr>
+          <p:cNvPicPr>
+            <a:picLocks noChangeAspect="1"/>
+          </p:cNvPicPr>
+          <p:nvPr/>
+        </p:nvPicPr>
+        <p:blipFill>
+          <a:blip r:embed="rId3"/>
+          <a:stretch>
+            <a:fillRect/>
+          </a:stretch>
+        </p:blipFill>
+        <p:spPr>
+          <a:xfrm>
+            <a:off x="4413490" y="4749388"/>
+            <a:ext cx="3943700" cy="1210505"/>
+          </a:xfrm>
+          <a:prstGeom prst="rect">
+            <a:avLst/>
+          </a:prstGeom>
+        </p:spPr>
+      </p:pic>
     </p:spTree>
     <p:extLst>
       <p:ext uri="{BB962C8B-B14F-4D97-AF65-F5344CB8AC3E}">
-        <p14:creationId xmlns:p14="http://schemas.microsoft.com/office/powerpoint/2010/main" val="2673586818"/>
+        <p14:creationId xmlns:p14="http://schemas.microsoft.com/office/powerpoint/2010/main" val="3536273638"/>
       </p:ext>
     </p:extLst>
   </p:cSld>
@@ -4090,7 +5692,7 @@
           <p:cNvPr id="2" name="标题 1">
             <a:extLst>
               <a:ext uri="{FF2B5EF4-FFF2-40B4-BE49-F238E27FC236}">
-                <a16:creationId xmlns:a16="http://schemas.microsoft.com/office/drawing/2014/main" id="{933A8942-61EA-6741-E001-6B19721BDB71}"/>
+                <a16:creationId xmlns:a16="http://schemas.microsoft.com/office/drawing/2014/main" id="{5DB5D596-DCB5-D892-2DD5-6E9CC32EEBDB}"/>
               </a:ext>
             </a:extLst>
           </p:cNvPr>
@@ -4099,11 +5701,184 @@
           </p:cNvSpPr>
           <p:nvPr>
             <p:ph type="title"/>
+          </p:nvPr>
+        </p:nvSpPr>
+        <p:spPr/>
+        <p:txBody>
+          <a:bodyPr/>
+          <a:lstStyle/>
+          <a:p>
+            <a:r>
+              <a:rPr lang="zh-CN" altLang="en-US" dirty="0"/>
+              <a:t>相关工作：</a:t>
+            </a:r>
+            <a:r>
+              <a:rPr lang="en-US" altLang="zh-CN" dirty="0" err="1"/>
+              <a:t>cuda</a:t>
+            </a:r>
+            <a:r>
+              <a:rPr lang="en-US" altLang="zh-CN" dirty="0"/>
+              <a:t>-optimized-skills</a:t>
+            </a:r>
+            <a:endParaRPr lang="zh-CN" altLang="en-US" dirty="0"/>
+          </a:p>
+        </p:txBody>
+      </p:sp>
+      <p:sp>
+        <p:nvSpPr>
+          <p:cNvPr id="3" name="内容占位符 2">
+            <a:extLst>
+              <a:ext uri="{FF2B5EF4-FFF2-40B4-BE49-F238E27FC236}">
+                <a16:creationId xmlns:a16="http://schemas.microsoft.com/office/drawing/2014/main" id="{F3DA9783-0049-33FE-5CCB-5E79B78A8A85}"/>
+              </a:ext>
+            </a:extLst>
+          </p:cNvPr>
+          <p:cNvSpPr>
+            <a:spLocks noGrp="1"/>
+          </p:cNvSpPr>
+          <p:nvPr>
+            <p:ph idx="1"/>
           </p:nvPr>
         </p:nvSpPr>
         <p:spPr>
           <a:xfrm>
-            <a:off x="882650" y="2766218"/>
+            <a:off x="838200" y="3428999"/>
+            <a:ext cx="10515600" cy="2747963"/>
+          </a:xfrm>
+        </p:spPr>
+        <p:txBody>
+          <a:bodyPr/>
+          <a:lstStyle/>
+          <a:p>
+            <a:r>
+              <a:rPr lang="zh-CN" altLang="zh-CN" dirty="0"/>
+              <a:t>从NVIDIA/NCU扩展到XSAI和国产芯片</a:t>
+            </a:r>
+          </a:p>
+          <a:p>
+            <a:r>
+              <a:rPr lang="zh-CN" altLang="zh-CN" dirty="0"/>
+              <a:t>从三类粗粒度指标扩展到细粒度瓶颈原因</a:t>
+            </a:r>
+          </a:p>
+          <a:p>
+            <a:r>
+              <a:rPr lang="en-US" altLang="zh-CN" dirty="0" err="1"/>
+              <a:t>FlagGems</a:t>
+            </a:r>
+            <a:r>
+              <a:rPr lang="zh-CN" altLang="en-US" dirty="0"/>
+              <a:t>数据</a:t>
+            </a:r>
+            <a:r>
+              <a:rPr lang="zh-CN" altLang="zh-CN" dirty="0"/>
+              <a:t>显式建立“证据—瓶颈—动作”的条件映射</a:t>
+            </a:r>
+          </a:p>
+          <a:p>
+            <a:r>
+              <a:rPr lang="zh-CN" altLang="zh-CN" dirty="0"/>
+              <a:t>用XSAI</a:t>
+            </a:r>
+            <a:r>
+              <a:rPr lang="zh-CN" altLang="en-US" dirty="0"/>
+              <a:t>白盒</a:t>
+            </a:r>
+            <a:r>
+              <a:rPr lang="zh-CN" altLang="zh-CN" dirty="0"/>
+              <a:t>验证动作机制</a:t>
+            </a:r>
+          </a:p>
+          <a:p>
+            <a:r>
+              <a:rPr lang="zh-CN" altLang="zh-CN" dirty="0"/>
+              <a:t>研究白盒知识向国产灰盒芯片的迁移</a:t>
+            </a:r>
+          </a:p>
+          <a:p>
+            <a:endParaRPr lang="zh-CN" altLang="en-US" dirty="0"/>
+          </a:p>
+        </p:txBody>
+      </p:sp>
+      <p:pic>
+        <p:nvPicPr>
+          <p:cNvPr id="5" name="图片 4">
+            <a:extLst>
+              <a:ext uri="{FF2B5EF4-FFF2-40B4-BE49-F238E27FC236}">
+                <a16:creationId xmlns:a16="http://schemas.microsoft.com/office/drawing/2014/main" id="{D1124723-1DE6-8B71-9CF3-42DB1D04F940}"/>
+              </a:ext>
+            </a:extLst>
+          </p:cNvPr>
+          <p:cNvPicPr>
+            <a:picLocks noChangeAspect="1"/>
+          </p:cNvPicPr>
+          <p:nvPr/>
+        </p:nvPicPr>
+        <p:blipFill>
+          <a:blip r:embed="rId3"/>
+          <a:stretch>
+            <a:fillRect/>
+          </a:stretch>
+        </p:blipFill>
+        <p:spPr>
+          <a:xfrm>
+            <a:off x="627086" y="1690688"/>
+            <a:ext cx="11171888" cy="1143099"/>
+          </a:xfrm>
+          <a:prstGeom prst="rect">
+            <a:avLst/>
+          </a:prstGeom>
+        </p:spPr>
+      </p:pic>
+    </p:spTree>
+    <p:extLst>
+      <p:ext uri="{BB962C8B-B14F-4D97-AF65-F5344CB8AC3E}">
+        <p14:creationId xmlns:p14="http://schemas.microsoft.com/office/powerpoint/2010/main" val="1373654373"/>
+      </p:ext>
+    </p:extLst>
+  </p:cSld>
+  <p:clrMapOvr>
+    <a:masterClrMapping/>
+  </p:clrMapOvr>
+</p:sld>
+</file>
+
+<file path=ppt/slides/slide9.xml><?xml version="1.0" encoding="utf-8"?>
+<p:sld xmlns:a="http://schemas.openxmlformats.org/drawingml/2006/main" xmlns:r="http://schemas.openxmlformats.org/officeDocument/2006/relationships" xmlns:p="http://schemas.openxmlformats.org/presentationml/2006/main">
+  <p:cSld>
+    <p:spTree>
+      <p:nvGrpSpPr>
+        <p:cNvPr id="1" name=""/>
+        <p:cNvGrpSpPr/>
+        <p:nvPr/>
+      </p:nvGrpSpPr>
+      <p:grpSpPr>
+        <a:xfrm>
+          <a:off x="0" y="0"/>
+          <a:ext cx="0" cy="0"/>
+          <a:chOff x="0" y="0"/>
+          <a:chExt cx="0" cy="0"/>
+        </a:xfrm>
+      </p:grpSpPr>
+      <p:sp>
+        <p:nvSpPr>
+          <p:cNvPr id="2" name="标题 1">
+            <a:extLst>
+              <a:ext uri="{FF2B5EF4-FFF2-40B4-BE49-F238E27FC236}">
+                <a16:creationId xmlns:a16="http://schemas.microsoft.com/office/drawing/2014/main" id="{14DBD51F-3C48-7850-1502-93D385F40BA6}"/>
+              </a:ext>
+            </a:extLst>
+          </p:cNvPr>
+          <p:cNvSpPr>
+            <a:spLocks noGrp="1"/>
+          </p:cNvSpPr>
+          <p:nvPr>
+            <p:ph type="title"/>
+          </p:nvPr>
+        </p:nvSpPr>
+        <p:spPr>
+          <a:xfrm>
+            <a:off x="838200" y="55016"/>
             <a:ext cx="10515600" cy="1325563"/>
           </a:xfrm>
         </p:spPr>
@@ -4111,18 +5886,270 @@
           <a:bodyPr/>
           <a:lstStyle/>
           <a:p>
-            <a:pPr algn="ctr"/>
+            <a:r>
+              <a:rPr lang="en-US" altLang="zh-CN" dirty="0"/>
+              <a:t>TODO</a:t>
+            </a:r>
+            <a:endParaRPr lang="zh-CN" altLang="en-US" dirty="0"/>
+          </a:p>
+        </p:txBody>
+      </p:sp>
+      <p:sp>
+        <p:nvSpPr>
+          <p:cNvPr id="3" name="内容占位符 2">
+            <a:extLst>
+              <a:ext uri="{FF2B5EF4-FFF2-40B4-BE49-F238E27FC236}">
+                <a16:creationId xmlns:a16="http://schemas.microsoft.com/office/drawing/2014/main" id="{5BBC1504-63C9-9883-52D6-DAAB4B59CF25}"/>
+              </a:ext>
+            </a:extLst>
+          </p:cNvPr>
+          <p:cNvSpPr>
+            <a:spLocks noGrp="1"/>
+          </p:cNvSpPr>
+          <p:nvPr>
+            <p:ph idx="1"/>
+          </p:nvPr>
+        </p:nvSpPr>
+        <p:spPr>
+          <a:xfrm>
+            <a:off x="838200" y="1515428"/>
+            <a:ext cx="10515600" cy="5287556"/>
+          </a:xfrm>
+        </p:spPr>
+        <p:txBody>
+          <a:bodyPr>
+            <a:normAutofit/>
+          </a:bodyPr>
+          <a:lstStyle/>
+          <a:p>
             <a:r>
               <a:rPr lang="zh-CN" altLang="en-US" dirty="0"/>
-              <a:t>请批评指正！</a:t>
-            </a:r>
+              <a:t>调研 </a:t>
+            </a:r>
+            <a:r>
+              <a:rPr lang="en-US" altLang="zh-CN" dirty="0" err="1"/>
+              <a:t>KernelGen</a:t>
+            </a:r>
+            <a:r>
+              <a:rPr lang="en-US" altLang="zh-CN" dirty="0"/>
+              <a:t> </a:t>
+            </a:r>
+            <a:r>
+              <a:rPr lang="zh-CN" altLang="en-US" dirty="0"/>
+              <a:t>现有的框架：接口确认</a:t>
+            </a:r>
+            <a:r>
+              <a:rPr lang="en-US" altLang="zh-CN" dirty="0"/>
+              <a:t>+</a:t>
+            </a:r>
+            <a:r>
+              <a:rPr lang="zh-CN" altLang="en-US" dirty="0"/>
+              <a:t>避免重复模块</a:t>
+            </a:r>
+            <a:endParaRPr lang="en-US" altLang="zh-CN" dirty="0"/>
+          </a:p>
+          <a:p>
+            <a:endParaRPr lang="en-US" altLang="zh-CN" dirty="0"/>
+          </a:p>
+          <a:p>
+            <a:r>
+              <a:rPr lang="zh-CN" altLang="en-US" dirty="0"/>
+              <a:t>厂商原始</a:t>
+            </a:r>
+            <a:r>
+              <a:rPr lang="en-US" altLang="zh-CN" dirty="0"/>
+              <a:t>profiling</a:t>
+            </a:r>
+            <a:r>
+              <a:rPr lang="zh-CN" altLang="en-US" dirty="0"/>
+              <a:t>信息</a:t>
+            </a:r>
+            <a:r>
+              <a:rPr lang="en-US" altLang="zh-CN" dirty="0"/>
+              <a:t>+</a:t>
+            </a:r>
+            <a:r>
+              <a:rPr lang="zh-CN" altLang="en-US" dirty="0"/>
+              <a:t>跨平台标准化证据</a:t>
+            </a:r>
+            <a:endParaRPr lang="en-US" altLang="zh-CN" dirty="0"/>
+          </a:p>
+          <a:p>
+            <a:pPr lvl="1"/>
+            <a:r>
+              <a:rPr lang="zh-CN" altLang="en-US" dirty="0"/>
+              <a:t>各个国产卡的</a:t>
+            </a:r>
+            <a:r>
+              <a:rPr lang="en-US" altLang="zh-CN" dirty="0"/>
+              <a:t>profiler</a:t>
+            </a:r>
+            <a:r>
+              <a:rPr lang="zh-CN" altLang="en-US" dirty="0"/>
+              <a:t>调研</a:t>
+            </a:r>
+            <a:endParaRPr lang="en-US" altLang="zh-CN" dirty="0"/>
+          </a:p>
+          <a:p>
+            <a:pPr lvl="1"/>
+            <a:r>
+              <a:rPr lang="zh-CN" altLang="en-US" dirty="0"/>
+              <a:t>与全集</a:t>
+            </a:r>
+            <a:r>
+              <a:rPr lang="en-US" altLang="zh-CN" dirty="0"/>
+              <a:t>XSAI/</a:t>
+            </a:r>
+            <a:r>
+              <a:rPr lang="zh-CN" altLang="en-US" dirty="0"/>
+              <a:t>成熟</a:t>
+            </a:r>
+            <a:r>
+              <a:rPr lang="en-US" altLang="zh-CN" dirty="0"/>
+              <a:t>NCU</a:t>
+            </a:r>
+            <a:r>
+              <a:rPr lang="zh-CN" altLang="en-US" dirty="0"/>
+              <a:t>对齐</a:t>
+            </a:r>
+            <a:endParaRPr lang="en-US" altLang="zh-CN" dirty="0"/>
+          </a:p>
+          <a:p>
+            <a:pPr lvl="1"/>
+            <a:endParaRPr lang="en-US" altLang="zh-CN" dirty="0"/>
+          </a:p>
+          <a:p>
+            <a:r>
+              <a:rPr lang="en-US" altLang="zh-CN" dirty="0"/>
+              <a:t>profiling</a:t>
+            </a:r>
+            <a:r>
+              <a:rPr lang="zh-CN" altLang="en-US" dirty="0"/>
+              <a:t>信息→细粒度瓶颈诊断→条件触发的候选动作：</a:t>
+            </a:r>
+            <a:endParaRPr lang="en-US" altLang="zh-CN" dirty="0"/>
+          </a:p>
+          <a:p>
+            <a:pPr lvl="1"/>
+            <a:r>
+              <a:rPr lang="zh-CN" altLang="en-US" dirty="0"/>
+              <a:t>详细调研</a:t>
+            </a:r>
+            <a:r>
+              <a:rPr lang="en-US" altLang="zh-CN" dirty="0" err="1"/>
+              <a:t>cuda</a:t>
+            </a:r>
+            <a:r>
+              <a:rPr lang="en-US" altLang="zh-CN" dirty="0"/>
+              <a:t>-optimized-skills</a:t>
+            </a:r>
+            <a:r>
+              <a:rPr lang="zh-CN" altLang="en-US" dirty="0"/>
+              <a:t>，迁移</a:t>
+            </a:r>
+            <a:endParaRPr lang="en-US" altLang="zh-CN" dirty="0"/>
+          </a:p>
+          <a:p>
+            <a:pPr lvl="1"/>
+            <a:r>
+              <a:rPr lang="zh-CN" altLang="en-US" dirty="0"/>
+              <a:t>映射建立（</a:t>
+            </a:r>
+            <a:r>
+              <a:rPr lang="en-US" altLang="zh-CN" dirty="0" err="1"/>
+              <a:t>XGBoost</a:t>
+            </a:r>
+            <a:r>
+              <a:rPr lang="zh-CN" altLang="en-US" dirty="0"/>
+              <a:t>模型训练</a:t>
+            </a:r>
+            <a:r>
+              <a:rPr lang="en-US" altLang="zh-CN" dirty="0"/>
+              <a:t>+SHAP</a:t>
+            </a:r>
+            <a:r>
+              <a:rPr lang="zh-CN" altLang="en-US" dirty="0"/>
+              <a:t>重要性筛选）</a:t>
+            </a:r>
+            <a:endParaRPr lang="en-US" altLang="zh-CN" dirty="0"/>
+          </a:p>
+          <a:p>
+            <a:pPr lvl="2"/>
+            <a:r>
+              <a:rPr lang="zh-CN" altLang="en-US" dirty="0"/>
+              <a:t>基于</a:t>
+            </a:r>
+            <a:r>
+              <a:rPr lang="en-US" altLang="zh-CN" dirty="0" err="1"/>
+              <a:t>FlagGems</a:t>
+            </a:r>
+            <a:r>
+              <a:rPr lang="zh-CN" altLang="en-US" dirty="0"/>
+              <a:t>真实</a:t>
+            </a:r>
+            <a:r>
+              <a:rPr lang="en-US" altLang="zh-CN" dirty="0"/>
+              <a:t>diff</a:t>
+            </a:r>
+            <a:r>
+              <a:rPr lang="zh-CN" altLang="en-US" dirty="0"/>
+              <a:t>：有无前后</a:t>
+            </a:r>
+            <a:r>
+              <a:rPr lang="en-US" altLang="zh-CN" dirty="0"/>
+              <a:t>profiling</a:t>
+            </a:r>
+            <a:r>
+              <a:rPr lang="zh-CN" altLang="en-US" dirty="0"/>
+              <a:t>数据？</a:t>
+            </a:r>
+            <a:endParaRPr lang="en-US" altLang="zh-CN" dirty="0"/>
+          </a:p>
+          <a:p>
+            <a:pPr lvl="2"/>
+            <a:r>
+              <a:rPr lang="en-US" altLang="zh-CN" dirty="0"/>
+              <a:t>XSAI</a:t>
+            </a:r>
+            <a:r>
+              <a:rPr lang="zh-CN" altLang="en-US" dirty="0"/>
+              <a:t>白盒重放：</a:t>
+            </a:r>
+            <a:r>
+              <a:rPr lang="en-US" altLang="zh-CN" dirty="0"/>
+              <a:t>profiling</a:t>
+            </a:r>
+            <a:r>
+              <a:rPr lang="zh-CN" altLang="en-US" dirty="0"/>
+              <a:t>全集到最小必要集合的科学筛选，简化映射的自变量端</a:t>
+            </a:r>
+            <a:endParaRPr lang="en-US" altLang="zh-CN" dirty="0"/>
+          </a:p>
+          <a:p>
+            <a:pPr lvl="2"/>
+            <a:r>
+              <a:rPr lang="zh-CN" altLang="en-US" dirty="0"/>
+              <a:t>国产卡的映射对齐：人工专家迁移</a:t>
+            </a:r>
+            <a:r>
+              <a:rPr lang="en-US" altLang="zh-CN" dirty="0"/>
+              <a:t>/</a:t>
+            </a:r>
+            <a:r>
+              <a:rPr lang="zh-CN" altLang="en-US" dirty="0"/>
+              <a:t>迁移学习算法</a:t>
+            </a:r>
+            <a:endParaRPr lang="en-US" altLang="zh-CN" dirty="0"/>
+          </a:p>
+          <a:p>
+            <a:endParaRPr lang="zh-CN" altLang="en-US" dirty="0"/>
           </a:p>
         </p:txBody>
       </p:sp>
     </p:spTree>
     <p:extLst>
       <p:ext uri="{BB962C8B-B14F-4D97-AF65-F5344CB8AC3E}">
-        <p14:creationId xmlns:p14="http://schemas.microsoft.com/office/powerpoint/2010/main" val="307437915"/>
+        <p14:creationId xmlns:p14="http://schemas.microsoft.com/office/powerpoint/2010/main" val="2673586818"/>
       </p:ext>
     </p:extLst>
   </p:cSld>
@@ -4425,4 +6452,299 @@
     </a:ext>
   </a:extLst>
 </a:theme>
+</file>
+
+<file path=ppt/theme/theme2.xml><?xml version="1.0" encoding="utf-8"?>
+<a:theme xmlns:a="http://schemas.openxmlformats.org/drawingml/2006/main" name="Office 主题​​">
+  <a:themeElements>
+    <a:clrScheme name="Office">
+      <a:dk1>
+        <a:sysClr val="windowText" lastClr="000000"/>
+      </a:dk1>
+      <a:lt1>
+        <a:sysClr val="window" lastClr="FFFFFF"/>
+      </a:lt1>
+      <a:dk2>
+        <a:srgbClr val="44546A"/>
+      </a:dk2>
+      <a:lt2>
+        <a:srgbClr val="E7E6E6"/>
+      </a:lt2>
+      <a:accent1>
+        <a:srgbClr val="4472C4"/>
+      </a:accent1>
+      <a:accent2>
+        <a:srgbClr val="ED7D31"/>
+      </a:accent2>
+      <a:accent3>
+        <a:srgbClr val="A5A5A5"/>
+      </a:accent3>
+      <a:accent4>
+        <a:srgbClr val="FFC000"/>
+      </a:accent4>
+      <a:accent5>
+        <a:srgbClr val="5B9BD5"/>
+      </a:accent5>
+      <a:accent6>
+        <a:srgbClr val="70AD47"/>
+      </a:accent6>
+      <a:hlink>
+        <a:srgbClr val="0563C1"/>
+      </a:hlink>
+      <a:folHlink>
+        <a:srgbClr val="954F72"/>
+      </a:folHlink>
+    </a:clrScheme>
+    <a:fontScheme name="Office">
+      <a:majorFont>
+        <a:latin typeface="等线 Light" panose="020F0302020204030204"/>
+        <a:ea typeface=""/>
+        <a:cs typeface=""/>
+        <a:font script="Jpan" typeface="游ゴシック Light"/>
+        <a:font script="Hang" typeface="맑은 고딕"/>
+        <a:font script="Hans" typeface="等线 Light"/>
+        <a:font script="Hant" typeface="新細明體"/>
+        <a:font script="Arab" typeface="Times New Roman"/>
+        <a:font script="Hebr" typeface="Times New Roman"/>
+        <a:font script="Thai" typeface="Angsana New"/>
+        <a:font script="Ethi" typeface="Nyala"/>
+        <a:font script="Beng" typeface="Vrinda"/>
+        <a:font script="Gujr" typeface="Shruti"/>
+        <a:font script="Khmr" typeface="MoolBoran"/>
+        <a:font script="Knda" typeface="Tunga"/>
+        <a:font script="Guru" typeface="Raavi"/>
+        <a:font script="Cans" typeface="Euphemia"/>
+        <a:font script="Cher" typeface="Plantagenet Cherokee"/>
+        <a:font script="Yiii" typeface="Microsoft Yi Baiti"/>
+        <a:font script="Tibt" typeface="Microsoft Himalaya"/>
+        <a:font script="Thaa" typeface="MV Boli"/>
+        <a:font script="Deva" typeface="Mangal"/>
+        <a:font script="Telu" typeface="Gautami"/>
+        <a:font script="Taml" typeface="Latha"/>
+        <a:font script="Syrc" typeface="Estrangelo Edessa"/>
+        <a:font script="Orya" typeface="Kalinga"/>
+        <a:font script="Mlym" typeface="Kartika"/>
+        <a:font script="Laoo" typeface="DokChampa"/>
+        <a:font script="Sinh" typeface="Iskoola Pota"/>
+        <a:font script="Mong" typeface="Mongolian Baiti"/>
+        <a:font script="Viet" typeface="Times New Roman"/>
+        <a:font script="Uigh" typeface="Microsoft Uighur"/>
+        <a:font script="Geor" typeface="Sylfaen"/>
+        <a:font script="Armn" typeface="Arial"/>
+        <a:font script="Bugi" typeface="Leelawadee UI"/>
+        <a:font script="Bopo" typeface="Microsoft JhengHei"/>
+        <a:font script="Java" typeface="Javanese Text"/>
+        <a:font script="Lisu" typeface="Segoe UI"/>
+        <a:font script="Mymr" typeface="Myanmar Text"/>
+        <a:font script="Nkoo" typeface="Ebrima"/>
+        <a:font script="Olck" typeface="Nirmala UI"/>
+        <a:font script="Osma" typeface="Ebrima"/>
+        <a:font script="Phag" typeface="Phagspa"/>
+        <a:font script="Syrn" typeface="Estrangelo Edessa"/>
+        <a:font script="Syrj" typeface="Estrangelo Edessa"/>
+        <a:font script="Syre" typeface="Estrangelo Edessa"/>
+        <a:font script="Sora" typeface="Nirmala UI"/>
+        <a:font script="Tale" typeface="Microsoft Tai Le"/>
+        <a:font script="Talu" typeface="Microsoft New Tai Lue"/>
+        <a:font script="Tfng" typeface="Ebrima"/>
+      </a:majorFont>
+      <a:minorFont>
+        <a:latin typeface="等线" panose="020F0502020204030204"/>
+        <a:ea typeface=""/>
+        <a:cs typeface=""/>
+        <a:font script="Jpan" typeface="游ゴシック"/>
+        <a:font script="Hang" typeface="맑은 고딕"/>
+        <a:font script="Hans" typeface="等线"/>
+        <a:font script="Hant" typeface="新細明體"/>
+        <a:font script="Arab" typeface="Arial"/>
+        <a:font script="Hebr" typeface="Arial"/>
+        <a:font script="Thai" typeface="Cordia New"/>
+        <a:font script="Ethi" typeface="Nyala"/>
+        <a:font script="Beng" typeface="Vrinda"/>
+        <a:font script="Gujr" typeface="Shruti"/>
+        <a:font script="Khmr" typeface="DaunPenh"/>
+        <a:font script="Knda" typeface="Tunga"/>
+        <a:font script="Guru" typeface="Raavi"/>
+        <a:font script="Cans" typeface="Euphemia"/>
+        <a:font script="Cher" typeface="Plantagenet Cherokee"/>
+        <a:font script="Yiii" typeface="Microsoft Yi Baiti"/>
+        <a:font script="Tibt" typeface="Microsoft Himalaya"/>
+        <a:font script="Thaa" typeface="MV Boli"/>
+        <a:font script="Deva" typeface="Mangal"/>
+        <a:font script="Telu" typeface="Gautami"/>
+        <a:font script="Taml" typeface="Latha"/>
+        <a:font script="Syrc" typeface="Estrangelo Edessa"/>
+        <a:font script="Orya" typeface="Kalinga"/>
+        <a:font script="Mlym" typeface="Kartika"/>
+        <a:font script="Laoo" typeface="DokChampa"/>
+        <a:font script="Sinh" typeface="Iskoola Pota"/>
+        <a:font script="Mong" typeface="Mongolian Baiti"/>
+        <a:font script="Viet" typeface="Arial"/>
+        <a:font script="Uigh" typeface="Microsoft Uighur"/>
+        <a:font script="Geor" typeface="Sylfaen"/>
+        <a:font script="Armn" typeface="Arial"/>
+        <a:font script="Bugi" typeface="Leelawadee UI"/>
+        <a:font script="Bopo" typeface="Microsoft JhengHei"/>
+        <a:font script="Java" typeface="Javanese Text"/>
+        <a:font script="Lisu" typeface="Segoe UI"/>
+        <a:font script="Mymr" typeface="Myanmar Text"/>
+        <a:font script="Nkoo" typeface="Ebrima"/>
+        <a:font script="Olck" typeface="Nirmala UI"/>
+        <a:font script="Osma" typeface="Ebrima"/>
+        <a:font script="Phag" typeface="Phagspa"/>
+        <a:font script="Syrn" typeface="Estrangelo Edessa"/>
+        <a:font script="Syrj" typeface="Estrangelo Edessa"/>
+        <a:font script="Syre" typeface="Estrangelo Edessa"/>
+        <a:font script="Sora" typeface="Nirmala UI"/>
+        <a:font script="Tale" typeface="Microsoft Tai Le"/>
+        <a:font script="Talu" typeface="Microsoft New Tai Lue"/>
+        <a:font script="Tfng" typeface="Ebrima"/>
+      </a:minorFont>
+    </a:fontScheme>
+    <a:fmtScheme name="Office">
+      <a:fillStyleLst>
+        <a:solidFill>
+          <a:schemeClr val="phClr"/>
+        </a:solidFill>
+        <a:gradFill rotWithShape="1">
+          <a:gsLst>
+            <a:gs pos="0">
+              <a:schemeClr val="phClr">
+                <a:lumMod val="110000"/>
+                <a:satMod val="105000"/>
+                <a:tint val="67000"/>
+              </a:schemeClr>
+            </a:gs>
+            <a:gs pos="50000">
+              <a:schemeClr val="phClr">
+                <a:lumMod val="105000"/>
+                <a:satMod val="103000"/>
+                <a:tint val="73000"/>
+              </a:schemeClr>
+            </a:gs>
+            <a:gs pos="100000">
+              <a:schemeClr val="phClr">
+                <a:lumMod val="105000"/>
+                <a:satMod val="109000"/>
+                <a:tint val="81000"/>
+              </a:schemeClr>
+            </a:gs>
+          </a:gsLst>
+          <a:lin ang="5400000" scaled="0"/>
+        </a:gradFill>
+        <a:gradFill rotWithShape="1">
+          <a:gsLst>
+            <a:gs pos="0">
+              <a:schemeClr val="phClr">
+                <a:satMod val="103000"/>
+                <a:lumMod val="102000"/>
+                <a:tint val="94000"/>
+              </a:schemeClr>
+            </a:gs>
+            <a:gs pos="50000">
+              <a:schemeClr val="phClr">
+                <a:satMod val="110000"/>
+                <a:lumMod val="100000"/>
+                <a:shade val="100000"/>
+              </a:schemeClr>
+            </a:gs>
+            <a:gs pos="100000">
+              <a:schemeClr val="phClr">
+                <a:lumMod val="99000"/>
+                <a:satMod val="120000"/>
+                <a:shade val="78000"/>
+              </a:schemeClr>
+            </a:gs>
+          </a:gsLst>
+          <a:lin ang="5400000" scaled="0"/>
+        </a:gradFill>
+      </a:fillStyleLst>
+      <a:lnStyleLst>
+        <a:ln w="6350" cap="flat" cmpd="sng" algn="ctr">
+          <a:solidFill>
+            <a:schemeClr val="phClr"/>
+          </a:solidFill>
+          <a:prstDash val="solid"/>
+          <a:miter lim="800000"/>
+        </a:ln>
+        <a:ln w="12700" cap="flat" cmpd="sng" algn="ctr">
+          <a:solidFill>
+            <a:schemeClr val="phClr"/>
+          </a:solidFill>
+          <a:prstDash val="solid"/>
+          <a:miter lim="800000"/>
+        </a:ln>
+        <a:ln w="19050" cap="flat" cmpd="sng" algn="ctr">
+          <a:solidFill>
+            <a:schemeClr val="phClr"/>
+          </a:solidFill>
+          <a:prstDash val="solid"/>
+          <a:miter lim="800000"/>
+        </a:ln>
+      </a:lnStyleLst>
+      <a:effectStyleLst>
+        <a:effectStyle>
+          <a:effectLst/>
+        </a:effectStyle>
+        <a:effectStyle>
+          <a:effectLst/>
+        </a:effectStyle>
+        <a:effectStyle>
+          <a:effectLst>
+            <a:outerShdw blurRad="57150" dist="19050" dir="5400000" algn="ctr" rotWithShape="0">
+              <a:srgbClr val="000000">
+                <a:alpha val="63000"/>
+              </a:srgbClr>
+            </a:outerShdw>
+          </a:effectLst>
+        </a:effectStyle>
+      </a:effectStyleLst>
+      <a:bgFillStyleLst>
+        <a:solidFill>
+          <a:schemeClr val="phClr"/>
+        </a:solidFill>
+        <a:solidFill>
+          <a:schemeClr val="phClr">
+            <a:tint val="95000"/>
+            <a:satMod val="170000"/>
+          </a:schemeClr>
+        </a:solidFill>
+        <a:gradFill rotWithShape="1">
+          <a:gsLst>
+            <a:gs pos="0">
+              <a:schemeClr val="phClr">
+                <a:tint val="93000"/>
+                <a:satMod val="150000"/>
+                <a:shade val="98000"/>
+                <a:lumMod val="102000"/>
+              </a:schemeClr>
+            </a:gs>
+            <a:gs pos="50000">
+              <a:schemeClr val="phClr">
+                <a:tint val="98000"/>
+                <a:satMod val="130000"/>
+                <a:shade val="90000"/>
+                <a:lumMod val="103000"/>
+              </a:schemeClr>
+            </a:gs>
+            <a:gs pos="100000">
+              <a:schemeClr val="phClr">
+                <a:shade val="63000"/>
+                <a:satMod val="120000"/>
+              </a:schemeClr>
+            </a:gs>
+          </a:gsLst>
+          <a:lin ang="5400000" scaled="0"/>
+        </a:gradFill>
+      </a:bgFillStyleLst>
+    </a:fmtScheme>
+  </a:themeElements>
+  <a:objectDefaults/>
+  <a:extraClrSchemeLst/>
+  <a:extLst>
+    <a:ext uri="{05A4C25C-085E-4340-85A3-A5531E510DB2}">
+      <thm15:themeFamily xmlns:thm15="http://schemas.microsoft.com/office/thememl/2012/main" name="Office Theme" id="{62F939B6-93AF-4DB8-9C6B-D6C7DFDC589F}" vid="{4A3C46E8-61CC-4603-A589-7422A47A8E4A}"/>
+    </a:ext>
+  </a:extLst>
+</a:theme>
 </file>
</xml_diff>